<commit_message>
Clarify engineering tests and leadership recommendation
</commit_message>
<xml_diff>
--- a/outputs/pipeline-playground-engineering-demo.pptx
+++ b/outputs/pipeline-playground-engineering-demo.pptx
@@ -2,21 +2,21 @@
 <file path=ppt/presentation.xml><?xml version="1.0" encoding="utf-8"?>
 <p:presentation xmlns:p="http://schemas.openxmlformats.org/presentationml/2006/main">
   <p:sldMasterIdLst>
-    <p:sldMasterId xmlns:r="http://schemas.openxmlformats.org/officeDocument/2006/relationships" id="2147483648" r:id="R3d9cc2a23432446d"/>
+    <p:sldMasterId xmlns:r="http://schemas.openxmlformats.org/officeDocument/2006/relationships" id="2147483648" r:id="R9e5dfc827c254dab"/>
   </p:sldMasterIdLst>
   <p:notesMasterIdLst>
-    <p:notesMasterId xmlns:r="http://schemas.openxmlformats.org/officeDocument/2006/relationships" r:id="R8c48ef29b0844bfc"/>
+    <p:notesMasterId xmlns:r="http://schemas.openxmlformats.org/officeDocument/2006/relationships" r:id="Rbfd948d62de44da7"/>
   </p:notesMasterIdLst>
   <p:sldIdLst>
-    <p:sldId xmlns:r="http://schemas.openxmlformats.org/officeDocument/2006/relationships" id="256" r:id="R7b74221406ff407f"/>
-    <p:sldId xmlns:r="http://schemas.openxmlformats.org/officeDocument/2006/relationships" id="257" r:id="Rb32352a9b35b468c"/>
-    <p:sldId xmlns:r="http://schemas.openxmlformats.org/officeDocument/2006/relationships" id="258" r:id="R35b923ef184a4bbf"/>
-    <p:sldId xmlns:r="http://schemas.openxmlformats.org/officeDocument/2006/relationships" id="259" r:id="Rf207c472d2814dea"/>
-    <p:sldId xmlns:r="http://schemas.openxmlformats.org/officeDocument/2006/relationships" id="260" r:id="Rb109397277ef4b54"/>
-    <p:sldId xmlns:r="http://schemas.openxmlformats.org/officeDocument/2006/relationships" id="261" r:id="R2e2ac6f2298b4d41"/>
-    <p:sldId xmlns:r="http://schemas.openxmlformats.org/officeDocument/2006/relationships" id="262" r:id="R898be6a6623f4cb2"/>
-    <p:sldId xmlns:r="http://schemas.openxmlformats.org/officeDocument/2006/relationships" id="263" r:id="R6d5873d160204ac3"/>
-    <p:sldId xmlns:r="http://schemas.openxmlformats.org/officeDocument/2006/relationships" id="264" r:id="R95fb7354e02c4e19"/>
+    <p:sldId xmlns:r="http://schemas.openxmlformats.org/officeDocument/2006/relationships" id="256" r:id="Rfa1342ea8f0548d4"/>
+    <p:sldId xmlns:r="http://schemas.openxmlformats.org/officeDocument/2006/relationships" id="257" r:id="R8c5d6cdd4eef4a95"/>
+    <p:sldId xmlns:r="http://schemas.openxmlformats.org/officeDocument/2006/relationships" id="258" r:id="R332250d188b44bfe"/>
+    <p:sldId xmlns:r="http://schemas.openxmlformats.org/officeDocument/2006/relationships" id="259" r:id="Rc0585e2628164ffe"/>
+    <p:sldId xmlns:r="http://schemas.openxmlformats.org/officeDocument/2006/relationships" id="260" r:id="R9c24fc5d97964456"/>
+    <p:sldId xmlns:r="http://schemas.openxmlformats.org/officeDocument/2006/relationships" id="261" r:id="Re0ee50135f2946a5"/>
+    <p:sldId xmlns:r="http://schemas.openxmlformats.org/officeDocument/2006/relationships" id="262" r:id="R4349b48596f6499c"/>
+    <p:sldId xmlns:r="http://schemas.openxmlformats.org/officeDocument/2006/relationships" id="263" r:id="R7b96e8f2ade24e49"/>
+    <p:sldId xmlns:r="http://schemas.openxmlformats.org/officeDocument/2006/relationships" id="264" r:id="Red5acd56387c4bd5"/>
   </p:sldIdLst>
   <p:sldSz cx="12192000" cy="6858000"/>
   <p:notesSz cx="6858000" cy="9144000"/>
@@ -1137,7 +1137,7 @@
   </p:cSld>
   <p:clrMap bg1="lt1" tx1="dk1" bg2="lt2" tx2="dk2" accent1="accent1" accent2="accent2" accent3="accent3" accent4="accent4" accent5="accent5" accent6="accent6" hlink="hlink" folHlink="folHlink"/>
   <p:sldLayoutIdLst>
-    <p:sldLayoutId xmlns:r="http://schemas.openxmlformats.org/officeDocument/2006/relationships" id="2147483649" r:id="Reb95a8e047234724"/>
+    <p:sldLayoutId xmlns:r="http://schemas.openxmlformats.org/officeDocument/2006/relationships" id="2147483649" r:id="Rb9c2101e60fd4b3e"/>
   </p:sldLayoutIdLst>
   <p:txStyles>
     <p:titleStyle>
@@ -1688,7 +1688,7 @@
           <p:cNvPr id="22" name="">
             <a:extLst xmlns:a="http://schemas.openxmlformats.org/drawingml/2006/main">
               <a:ext uri="{FF2B5EF4-FFF2-40B4-BE49-F238E27FC236}">
-                <a16:creationId xmlns:a16="http://schemas.microsoft.com/office/drawing/2014/main" id="{FA3709E3-A3FE-4A31-AE47-BF253CF819F8}"/>
+                <a16:creationId xmlns:a16="http://schemas.microsoft.com/office/drawing/2014/main" id="{F6D6AD7C-DDD1-46BC-84AE-DDF545645A55}"/>
               </a:ext>
             </a:extLst>
           </p:cNvPr>
@@ -1719,7 +1719,7 @@
           <p:cNvPr id="2" name="">
             <a:extLst xmlns:a="http://schemas.openxmlformats.org/drawingml/2006/main">
               <a:ext uri="{FF2B5EF4-FFF2-40B4-BE49-F238E27FC236}">
-                <a16:creationId xmlns:a16="http://schemas.microsoft.com/office/drawing/2014/main" id="{33775140-62DE-4BE0-B99C-DF96D6EBD118}"/>
+                <a16:creationId xmlns:a16="http://schemas.microsoft.com/office/drawing/2014/main" id="{A9788309-B4FF-4335-83DA-6C5BC68D24CC}"/>
               </a:ext>
             </a:extLst>
           </p:cNvPr>
@@ -1750,7 +1750,7 @@
           <p:cNvPr id="3" name="">
             <a:extLst xmlns:a="http://schemas.openxmlformats.org/drawingml/2006/main">
               <a:ext uri="{FF2B5EF4-FFF2-40B4-BE49-F238E27FC236}">
-                <a16:creationId xmlns:a16="http://schemas.microsoft.com/office/drawing/2014/main" id="{B28626D8-E1EA-41E2-9459-3200EE14D31E}"/>
+                <a16:creationId xmlns:a16="http://schemas.microsoft.com/office/drawing/2014/main" id="{17CADB06-7E6F-4D1E-ACB8-BE0653EA5497}"/>
               </a:ext>
             </a:extLst>
           </p:cNvPr>
@@ -1800,7 +1800,7 @@
           <p:cNvPr id="4" name="">
             <a:extLst xmlns:a="http://schemas.openxmlformats.org/drawingml/2006/main">
               <a:ext uri="{FF2B5EF4-FFF2-40B4-BE49-F238E27FC236}">
-                <a16:creationId xmlns:a16="http://schemas.microsoft.com/office/drawing/2014/main" id="{22A4E387-166C-44A7-A86B-4BF1BD89CA03}"/>
+                <a16:creationId xmlns:a16="http://schemas.microsoft.com/office/drawing/2014/main" id="{68B7D54F-FC78-46BE-84AC-A4AE40D70D91}"/>
               </a:ext>
             </a:extLst>
           </p:cNvPr>
@@ -1867,7 +1867,7 @@
           <p:cNvPr id="5" name="">
             <a:extLst xmlns:a="http://schemas.openxmlformats.org/drawingml/2006/main">
               <a:ext uri="{FF2B5EF4-FFF2-40B4-BE49-F238E27FC236}">
-                <a16:creationId xmlns:a16="http://schemas.microsoft.com/office/drawing/2014/main" id="{D941C386-2FF1-4323-8A30-58E78A201D50}"/>
+                <a16:creationId xmlns:a16="http://schemas.microsoft.com/office/drawing/2014/main" id="{5E9A9222-0FDF-43AD-954D-378C9F43978D}"/>
               </a:ext>
             </a:extLst>
           </p:cNvPr>
@@ -1917,7 +1917,7 @@
           <p:cNvPr id="6" name="">
             <a:extLst xmlns:a="http://schemas.openxmlformats.org/drawingml/2006/main">
               <a:ext uri="{FF2B5EF4-FFF2-40B4-BE49-F238E27FC236}">
-                <a16:creationId xmlns:a16="http://schemas.microsoft.com/office/drawing/2014/main" id="{68E2D4DA-92E2-411B-BC49-DBF6BACC43BC}"/>
+                <a16:creationId xmlns:a16="http://schemas.microsoft.com/office/drawing/2014/main" id="{8EE097FF-ECDB-47C2-976D-A2EC12950001}"/>
               </a:ext>
             </a:extLst>
           </p:cNvPr>
@@ -1952,7 +1952,7 @@
           <p:cNvPr id="7" name="">
             <a:extLst xmlns:a="http://schemas.openxmlformats.org/drawingml/2006/main">
               <a:ext uri="{FF2B5EF4-FFF2-40B4-BE49-F238E27FC236}">
-                <a16:creationId xmlns:a16="http://schemas.microsoft.com/office/drawing/2014/main" id="{B4C7525B-A8D3-4366-AFBE-8A15211F371C}"/>
+                <a16:creationId xmlns:a16="http://schemas.microsoft.com/office/drawing/2014/main" id="{AF39A84E-7FB6-4473-9335-EC3303DCDA5C}"/>
               </a:ext>
             </a:extLst>
           </p:cNvPr>
@@ -1985,7 +1985,7 @@
           <p:cNvPr id="8" name="">
             <a:extLst xmlns:a="http://schemas.openxmlformats.org/drawingml/2006/main">
               <a:ext uri="{FF2B5EF4-FFF2-40B4-BE49-F238E27FC236}">
-                <a16:creationId xmlns:a16="http://schemas.microsoft.com/office/drawing/2014/main" id="{75DC8799-824F-4FEC-B495-2F35E9DC63D4}"/>
+                <a16:creationId xmlns:a16="http://schemas.microsoft.com/office/drawing/2014/main" id="{2D9414FB-AEE8-4101-B943-521BA67FCB79}"/>
               </a:ext>
             </a:extLst>
           </p:cNvPr>
@@ -2035,7 +2035,7 @@
           <p:cNvPr id="9" name="">
             <a:extLst xmlns:a="http://schemas.openxmlformats.org/drawingml/2006/main">
               <a:ext uri="{FF2B5EF4-FFF2-40B4-BE49-F238E27FC236}">
-                <a16:creationId xmlns:a16="http://schemas.microsoft.com/office/drawing/2014/main" id="{F3B1A633-8E0F-4D11-9B61-AA95066CA880}"/>
+                <a16:creationId xmlns:a16="http://schemas.microsoft.com/office/drawing/2014/main" id="{22F87888-EDD5-45F4-988C-FABD4E74E32F}"/>
               </a:ext>
             </a:extLst>
           </p:cNvPr>
@@ -2085,7 +2085,7 @@
           <p:cNvPr id="10" name="">
             <a:extLst xmlns:a="http://schemas.openxmlformats.org/drawingml/2006/main">
               <a:ext uri="{FF2B5EF4-FFF2-40B4-BE49-F238E27FC236}">
-                <a16:creationId xmlns:a16="http://schemas.microsoft.com/office/drawing/2014/main" id="{D961DFFA-FE65-46AC-9F91-A27C3B314996}"/>
+                <a16:creationId xmlns:a16="http://schemas.microsoft.com/office/drawing/2014/main" id="{9BD4A294-6AB8-4E88-BD0E-E6FB3A24F622}"/>
               </a:ext>
             </a:extLst>
           </p:cNvPr>
@@ -2135,7 +2135,7 @@
           <p:cNvPr id="11" name="">
             <a:extLst xmlns:a="http://schemas.openxmlformats.org/drawingml/2006/main">
               <a:ext uri="{FF2B5EF4-FFF2-40B4-BE49-F238E27FC236}">
-                <a16:creationId xmlns:a16="http://schemas.microsoft.com/office/drawing/2014/main" id="{23AF99D4-51A6-4E8E-9BF7-8F2FFECEB4AC}"/>
+                <a16:creationId xmlns:a16="http://schemas.microsoft.com/office/drawing/2014/main" id="{E83B8776-6601-4E81-8A86-73EDA833B1E4}"/>
               </a:ext>
             </a:extLst>
           </p:cNvPr>
@@ -2185,7 +2185,7 @@
           <p:cNvPr id="12" name="">
             <a:extLst xmlns:a="http://schemas.openxmlformats.org/drawingml/2006/main">
               <a:ext uri="{FF2B5EF4-FFF2-40B4-BE49-F238E27FC236}">
-                <a16:creationId xmlns:a16="http://schemas.microsoft.com/office/drawing/2014/main" id="{87A68F85-B7E1-4BC9-BB3B-777A04E054C4}"/>
+                <a16:creationId xmlns:a16="http://schemas.microsoft.com/office/drawing/2014/main" id="{BAE317A5-6C66-417F-897F-8EC3D16C29E8}"/>
               </a:ext>
             </a:extLst>
           </p:cNvPr>
@@ -2235,7 +2235,7 @@
           <p:cNvPr id="13" name="">
             <a:extLst xmlns:a="http://schemas.openxmlformats.org/drawingml/2006/main">
               <a:ext uri="{FF2B5EF4-FFF2-40B4-BE49-F238E27FC236}">
-                <a16:creationId xmlns:a16="http://schemas.microsoft.com/office/drawing/2014/main" id="{B196A4E6-7BFB-4339-89D0-2586DFDC0AB1}"/>
+                <a16:creationId xmlns:a16="http://schemas.microsoft.com/office/drawing/2014/main" id="{9FB526E1-BF5D-45D1-A536-9E1080513427}"/>
               </a:ext>
             </a:extLst>
           </p:cNvPr>
@@ -2285,7 +2285,7 @@
           <p:cNvPr id="14" name="">
             <a:extLst xmlns:a="http://schemas.openxmlformats.org/drawingml/2006/main">
               <a:ext uri="{FF2B5EF4-FFF2-40B4-BE49-F238E27FC236}">
-                <a16:creationId xmlns:a16="http://schemas.microsoft.com/office/drawing/2014/main" id="{EB6A93D7-983D-475C-8250-D8CCAD984AA2}"/>
+                <a16:creationId xmlns:a16="http://schemas.microsoft.com/office/drawing/2014/main" id="{54222045-F48B-4F86-B452-92AB5C4164C1}"/>
               </a:ext>
             </a:extLst>
           </p:cNvPr>
@@ -2335,7 +2335,7 @@
           <p:cNvPr id="15" name="">
             <a:extLst xmlns:a="http://schemas.openxmlformats.org/drawingml/2006/main">
               <a:ext uri="{FF2B5EF4-FFF2-40B4-BE49-F238E27FC236}">
-                <a16:creationId xmlns:a16="http://schemas.microsoft.com/office/drawing/2014/main" id="{71B8F786-E5EA-4973-A611-3F8720993D27}"/>
+                <a16:creationId xmlns:a16="http://schemas.microsoft.com/office/drawing/2014/main" id="{0FE3DD8F-B01D-4BBC-8551-670895B8A660}"/>
               </a:ext>
             </a:extLst>
           </p:cNvPr>
@@ -2385,7 +2385,7 @@
           <p:cNvPr id="16" name="">
             <a:extLst xmlns:a="http://schemas.openxmlformats.org/drawingml/2006/main">
               <a:ext uri="{FF2B5EF4-FFF2-40B4-BE49-F238E27FC236}">
-                <a16:creationId xmlns:a16="http://schemas.microsoft.com/office/drawing/2014/main" id="{BBC95EC9-3899-44FD-B88A-1E6966866C02}"/>
+                <a16:creationId xmlns:a16="http://schemas.microsoft.com/office/drawing/2014/main" id="{510A7DB2-1D77-4F3E-916D-DFC7EC9DCFF4}"/>
               </a:ext>
             </a:extLst>
           </p:cNvPr>
@@ -2435,7 +2435,7 @@
           <p:cNvPr id="17" name="">
             <a:extLst xmlns:a="http://schemas.openxmlformats.org/drawingml/2006/main">
               <a:ext uri="{FF2B5EF4-FFF2-40B4-BE49-F238E27FC236}">
-                <a16:creationId xmlns:a16="http://schemas.microsoft.com/office/drawing/2014/main" id="{B13B0A13-AFD6-413D-9A12-2B2CB4DDEE26}"/>
+                <a16:creationId xmlns:a16="http://schemas.microsoft.com/office/drawing/2014/main" id="{6386E3C0-3BA6-4FE8-A7F3-F6DE0008372D}"/>
               </a:ext>
             </a:extLst>
           </p:cNvPr>
@@ -2485,7 +2485,7 @@
           <p:cNvPr id="18" name="">
             <a:extLst xmlns:a="http://schemas.openxmlformats.org/drawingml/2006/main">
               <a:ext uri="{FF2B5EF4-FFF2-40B4-BE49-F238E27FC236}">
-                <a16:creationId xmlns:a16="http://schemas.microsoft.com/office/drawing/2014/main" id="{192CB6DE-594A-4971-8813-829FDD7D8B8B}"/>
+                <a16:creationId xmlns:a16="http://schemas.microsoft.com/office/drawing/2014/main" id="{B995E0E6-4700-469E-BA93-E901FF852459}"/>
               </a:ext>
             </a:extLst>
           </p:cNvPr>
@@ -2535,7 +2535,7 @@
           <p:cNvPr id="19" name="">
             <a:extLst xmlns:a="http://schemas.openxmlformats.org/drawingml/2006/main">
               <a:ext uri="{FF2B5EF4-FFF2-40B4-BE49-F238E27FC236}">
-                <a16:creationId xmlns:a16="http://schemas.microsoft.com/office/drawing/2014/main" id="{534BF64F-F631-4DCB-AAE2-6109C33ACF5E}"/>
+                <a16:creationId xmlns:a16="http://schemas.microsoft.com/office/drawing/2014/main" id="{767BB13C-0175-4A31-9E8C-A846ED025B78}"/>
               </a:ext>
             </a:extLst>
           </p:cNvPr>
@@ -2585,7 +2585,7 @@
           <p:cNvPr id="20" name="">
             <a:extLst xmlns:a="http://schemas.openxmlformats.org/drawingml/2006/main">
               <a:ext uri="{FF2B5EF4-FFF2-40B4-BE49-F238E27FC236}">
-                <a16:creationId xmlns:a16="http://schemas.microsoft.com/office/drawing/2014/main" id="{0D9E7445-FD4B-45DB-9B5A-2D193C0FA3B4}"/>
+                <a16:creationId xmlns:a16="http://schemas.microsoft.com/office/drawing/2014/main" id="{01DAD72C-1D68-419B-8E7C-1B3125755765}"/>
               </a:ext>
             </a:extLst>
           </p:cNvPr>
@@ -2635,7 +2635,7 @@
           <p:cNvPr id="21" name="">
             <a:extLst xmlns:a="http://schemas.openxmlformats.org/drawingml/2006/main">
               <a:ext uri="{FF2B5EF4-FFF2-40B4-BE49-F238E27FC236}">
-                <a16:creationId xmlns:a16="http://schemas.microsoft.com/office/drawing/2014/main" id="{25CE83A0-59A9-4C3A-8AFE-2AC81A4A54CD}"/>
+                <a16:creationId xmlns:a16="http://schemas.microsoft.com/office/drawing/2014/main" id="{AA279883-43C0-41F4-B827-B53A4C026355}"/>
               </a:ext>
             </a:extLst>
           </p:cNvPr>
@@ -2683,7 +2683,7 @@
     </p:spTree>
     <p:extLst>
       <p:ext uri="{BB962C8B-B14F-4D97-AF65-F5344CB8AC3E}">
-        <p14:creationId xmlns:p14="http://schemas.microsoft.com/office/powerpoint/2010/main" val="855268622"/>
+        <p14:creationId xmlns:p14="http://schemas.microsoft.com/office/powerpoint/2010/main" val="1414669111"/>
       </p:ext>
     </p:extLst>
   </p:cSld>
@@ -2714,7 +2714,7 @@
           <p:cNvPr id="22" name="">
             <a:extLst xmlns:a="http://schemas.openxmlformats.org/drawingml/2006/main">
               <a:ext uri="{FF2B5EF4-FFF2-40B4-BE49-F238E27FC236}">
-                <a16:creationId xmlns:a16="http://schemas.microsoft.com/office/drawing/2014/main" id="{9A89E4A1-F885-4B64-A7F4-6E1C423B62BE}"/>
+                <a16:creationId xmlns:a16="http://schemas.microsoft.com/office/drawing/2014/main" id="{A9122218-6F5D-4B2E-A52D-AE82FD62D8EB}"/>
               </a:ext>
             </a:extLst>
           </p:cNvPr>
@@ -2745,7 +2745,7 @@
           <p:cNvPr id="2" name="">
             <a:extLst xmlns:a="http://schemas.openxmlformats.org/drawingml/2006/main">
               <a:ext uri="{FF2B5EF4-FFF2-40B4-BE49-F238E27FC236}">
-                <a16:creationId xmlns:a16="http://schemas.microsoft.com/office/drawing/2014/main" id="{DC0C392C-59D2-423B-8B4B-01FFB44FBBB7}"/>
+                <a16:creationId xmlns:a16="http://schemas.microsoft.com/office/drawing/2014/main" id="{51150D2D-A995-4073-89E8-ADCDC67AFCB8}"/>
               </a:ext>
             </a:extLst>
           </p:cNvPr>
@@ -2795,7 +2795,7 @@
           <p:cNvPr id="3" name="">
             <a:extLst xmlns:a="http://schemas.openxmlformats.org/drawingml/2006/main">
               <a:ext uri="{FF2B5EF4-FFF2-40B4-BE49-F238E27FC236}">
-                <a16:creationId xmlns:a16="http://schemas.microsoft.com/office/drawing/2014/main" id="{597099AB-E2C1-4AA2-BC0C-DB8B3D9162E1}"/>
+                <a16:creationId xmlns:a16="http://schemas.microsoft.com/office/drawing/2014/main" id="{F2672409-FE2F-468B-B4B6-03C1512BCCC1}"/>
               </a:ext>
             </a:extLst>
           </p:cNvPr>
@@ -2845,7 +2845,7 @@
           <p:cNvPr id="4" name="">
             <a:extLst xmlns:a="http://schemas.openxmlformats.org/drawingml/2006/main">
               <a:ext uri="{FF2B5EF4-FFF2-40B4-BE49-F238E27FC236}">
-                <a16:creationId xmlns:a16="http://schemas.microsoft.com/office/drawing/2014/main" id="{81ACBA35-136A-4709-9E70-66F9B7CE8180}"/>
+                <a16:creationId xmlns:a16="http://schemas.microsoft.com/office/drawing/2014/main" id="{72070CD9-3089-4DC9-B921-71764F825902}"/>
               </a:ext>
             </a:extLst>
           </p:cNvPr>
@@ -2876,7 +2876,7 @@
           <p:cNvPr id="5" name="">
             <a:extLst xmlns:a="http://schemas.openxmlformats.org/drawingml/2006/main">
               <a:ext uri="{FF2B5EF4-FFF2-40B4-BE49-F238E27FC236}">
-                <a16:creationId xmlns:a16="http://schemas.microsoft.com/office/drawing/2014/main" id="{D8F2CCC9-4367-41AD-A55F-5D916522D188}"/>
+                <a16:creationId xmlns:a16="http://schemas.microsoft.com/office/drawing/2014/main" id="{DEA2A1A3-64AF-4D2B-9AF9-87E28A14905D}"/>
               </a:ext>
             </a:extLst>
           </p:cNvPr>
@@ -2926,7 +2926,7 @@
           <p:cNvPr id="6" name="">
             <a:extLst xmlns:a="http://schemas.openxmlformats.org/drawingml/2006/main">
               <a:ext uri="{FF2B5EF4-FFF2-40B4-BE49-F238E27FC236}">
-                <a16:creationId xmlns:a16="http://schemas.microsoft.com/office/drawing/2014/main" id="{AD2E49BA-5893-49B3-8BB3-461483580BB4}"/>
+                <a16:creationId xmlns:a16="http://schemas.microsoft.com/office/drawing/2014/main" id="{C0CFD90F-7FFA-4EA0-B004-3DF1C54D4F31}"/>
               </a:ext>
             </a:extLst>
           </p:cNvPr>
@@ -2976,7 +2976,7 @@
           <p:cNvPr id="7" name="">
             <a:extLst xmlns:a="http://schemas.openxmlformats.org/drawingml/2006/main">
               <a:ext uri="{FF2B5EF4-FFF2-40B4-BE49-F238E27FC236}">
-                <a16:creationId xmlns:a16="http://schemas.microsoft.com/office/drawing/2014/main" id="{E180AD62-EEB1-4251-B08B-05C65C734A05}"/>
+                <a16:creationId xmlns:a16="http://schemas.microsoft.com/office/drawing/2014/main" id="{DEBDE8F0-C2E0-424B-A620-8C1505F0106C}"/>
               </a:ext>
             </a:extLst>
           </p:cNvPr>
@@ -3009,7 +3009,7 @@
           <p:cNvPr id="8" name="">
             <a:extLst xmlns:a="http://schemas.openxmlformats.org/drawingml/2006/main">
               <a:ext uri="{FF2B5EF4-FFF2-40B4-BE49-F238E27FC236}">
-                <a16:creationId xmlns:a16="http://schemas.microsoft.com/office/drawing/2014/main" id="{88F591E0-C12A-4602-BBAB-33409A359B54}"/>
+                <a16:creationId xmlns:a16="http://schemas.microsoft.com/office/drawing/2014/main" id="{EA6C58E3-D0CF-4E14-B8B1-11D10DFD8C51}"/>
               </a:ext>
             </a:extLst>
           </p:cNvPr>
@@ -3059,7 +3059,7 @@
           <p:cNvPr id="9" name="">
             <a:extLst xmlns:a="http://schemas.openxmlformats.org/drawingml/2006/main">
               <a:ext uri="{FF2B5EF4-FFF2-40B4-BE49-F238E27FC236}">
-                <a16:creationId xmlns:a16="http://schemas.microsoft.com/office/drawing/2014/main" id="{87624A95-8107-4B25-AC55-535812F72216}"/>
+                <a16:creationId xmlns:a16="http://schemas.microsoft.com/office/drawing/2014/main" id="{9ADC1D9E-613B-426D-8BBD-25871EC75637}"/>
               </a:ext>
             </a:extLst>
           </p:cNvPr>
@@ -3094,7 +3094,7 @@
           <p:cNvPr id="10" name="">
             <a:extLst xmlns:a="http://schemas.openxmlformats.org/drawingml/2006/main">
               <a:ext uri="{FF2B5EF4-FFF2-40B4-BE49-F238E27FC236}">
-                <a16:creationId xmlns:a16="http://schemas.microsoft.com/office/drawing/2014/main" id="{679CF73E-CA57-4382-9F6B-0BA4A5D15F4A}"/>
+                <a16:creationId xmlns:a16="http://schemas.microsoft.com/office/drawing/2014/main" id="{C42176E1-96B4-4B66-B6A0-73CA4C3D5516}"/>
               </a:ext>
             </a:extLst>
           </p:cNvPr>
@@ -3144,7 +3144,7 @@
           <p:cNvPr id="11" name="">
             <a:extLst xmlns:a="http://schemas.openxmlformats.org/drawingml/2006/main">
               <a:ext uri="{FF2B5EF4-FFF2-40B4-BE49-F238E27FC236}">
-                <a16:creationId xmlns:a16="http://schemas.microsoft.com/office/drawing/2014/main" id="{85B2A002-D2D4-42E2-B851-4B192B809C19}"/>
+                <a16:creationId xmlns:a16="http://schemas.microsoft.com/office/drawing/2014/main" id="{982E963C-966B-4C17-A3C3-9B8D5F562304}"/>
               </a:ext>
             </a:extLst>
           </p:cNvPr>
@@ -3194,7 +3194,7 @@
           <p:cNvPr id="12" name="">
             <a:extLst xmlns:a="http://schemas.openxmlformats.org/drawingml/2006/main">
               <a:ext uri="{FF2B5EF4-FFF2-40B4-BE49-F238E27FC236}">
-                <a16:creationId xmlns:a16="http://schemas.microsoft.com/office/drawing/2014/main" id="{9D3E44A9-4BCD-4303-BA2A-A79AACAC158F}"/>
+                <a16:creationId xmlns:a16="http://schemas.microsoft.com/office/drawing/2014/main" id="{41EF881B-6DD0-4371-849B-B0BE0827E5B6}"/>
               </a:ext>
             </a:extLst>
           </p:cNvPr>
@@ -3229,7 +3229,7 @@
           <p:cNvPr id="13" name="">
             <a:extLst xmlns:a="http://schemas.openxmlformats.org/drawingml/2006/main">
               <a:ext uri="{FF2B5EF4-FFF2-40B4-BE49-F238E27FC236}">
-                <a16:creationId xmlns:a16="http://schemas.microsoft.com/office/drawing/2014/main" id="{6BB89692-6943-4A5F-B422-B0E2147CADC4}"/>
+                <a16:creationId xmlns:a16="http://schemas.microsoft.com/office/drawing/2014/main" id="{BAB5CD02-59B5-4B91-8CC1-F031809016ED}"/>
               </a:ext>
             </a:extLst>
           </p:cNvPr>
@@ -3279,7 +3279,7 @@
           <p:cNvPr id="14" name="">
             <a:extLst xmlns:a="http://schemas.openxmlformats.org/drawingml/2006/main">
               <a:ext uri="{FF2B5EF4-FFF2-40B4-BE49-F238E27FC236}">
-                <a16:creationId xmlns:a16="http://schemas.microsoft.com/office/drawing/2014/main" id="{EE277773-88B2-4EA8-9B7F-1C9FB28CBE2F}"/>
+                <a16:creationId xmlns:a16="http://schemas.microsoft.com/office/drawing/2014/main" id="{FB688071-BCE0-4E4E-84D6-302BA4C8F7C1}"/>
               </a:ext>
             </a:extLst>
           </p:cNvPr>
@@ -3329,7 +3329,7 @@
           <p:cNvPr id="15" name="">
             <a:extLst xmlns:a="http://schemas.openxmlformats.org/drawingml/2006/main">
               <a:ext uri="{FF2B5EF4-FFF2-40B4-BE49-F238E27FC236}">
-                <a16:creationId xmlns:a16="http://schemas.microsoft.com/office/drawing/2014/main" id="{5A3D7DA0-65D9-4B90-ABEF-B398CD11181C}"/>
+                <a16:creationId xmlns:a16="http://schemas.microsoft.com/office/drawing/2014/main" id="{2322F7C6-F54F-42E1-9B58-3D0D200F3246}"/>
               </a:ext>
             </a:extLst>
           </p:cNvPr>
@@ -3364,7 +3364,7 @@
           <p:cNvPr id="16" name="">
             <a:extLst xmlns:a="http://schemas.openxmlformats.org/drawingml/2006/main">
               <a:ext uri="{FF2B5EF4-FFF2-40B4-BE49-F238E27FC236}">
-                <a16:creationId xmlns:a16="http://schemas.microsoft.com/office/drawing/2014/main" id="{2E6AEDA4-3C57-4B93-85F2-02FEA8E14758}"/>
+                <a16:creationId xmlns:a16="http://schemas.microsoft.com/office/drawing/2014/main" id="{A0AA056F-4D87-4B64-882A-15250C370BCD}"/>
               </a:ext>
             </a:extLst>
           </p:cNvPr>
@@ -3414,7 +3414,7 @@
           <p:cNvPr id="17" name="">
             <a:extLst xmlns:a="http://schemas.openxmlformats.org/drawingml/2006/main">
               <a:ext uri="{FF2B5EF4-FFF2-40B4-BE49-F238E27FC236}">
-                <a16:creationId xmlns:a16="http://schemas.microsoft.com/office/drawing/2014/main" id="{904BC3C5-5FBA-4312-943A-E42F74FC3207}"/>
+                <a16:creationId xmlns:a16="http://schemas.microsoft.com/office/drawing/2014/main" id="{859E3B05-4DAB-448C-B38A-B96E22B48B24}"/>
               </a:ext>
             </a:extLst>
           </p:cNvPr>
@@ -3464,7 +3464,7 @@
           <p:cNvPr id="18" name="">
             <a:extLst xmlns:a="http://schemas.openxmlformats.org/drawingml/2006/main">
               <a:ext uri="{FF2B5EF4-FFF2-40B4-BE49-F238E27FC236}">
-                <a16:creationId xmlns:a16="http://schemas.microsoft.com/office/drawing/2014/main" id="{F12CCB6C-5A32-4E3B-8F0E-21CB3F8D58B3}"/>
+                <a16:creationId xmlns:a16="http://schemas.microsoft.com/office/drawing/2014/main" id="{6E730FAC-619B-401C-8540-792D9EA8423E}"/>
               </a:ext>
             </a:extLst>
           </p:cNvPr>
@@ -3499,7 +3499,7 @@
           <p:cNvPr id="19" name="">
             <a:extLst xmlns:a="http://schemas.openxmlformats.org/drawingml/2006/main">
               <a:ext uri="{FF2B5EF4-FFF2-40B4-BE49-F238E27FC236}">
-                <a16:creationId xmlns:a16="http://schemas.microsoft.com/office/drawing/2014/main" id="{751494AE-BF84-42EB-923F-F6EB459321BF}"/>
+                <a16:creationId xmlns:a16="http://schemas.microsoft.com/office/drawing/2014/main" id="{32EA6B12-367D-4583-AE10-B406C0A5288A}"/>
               </a:ext>
             </a:extLst>
           </p:cNvPr>
@@ -3549,7 +3549,7 @@
           <p:cNvPr id="20" name="">
             <a:extLst xmlns:a="http://schemas.openxmlformats.org/drawingml/2006/main">
               <a:ext uri="{FF2B5EF4-FFF2-40B4-BE49-F238E27FC236}">
-                <a16:creationId xmlns:a16="http://schemas.microsoft.com/office/drawing/2014/main" id="{0E35277D-C31A-4F4A-B2D7-0899BD369E64}"/>
+                <a16:creationId xmlns:a16="http://schemas.microsoft.com/office/drawing/2014/main" id="{5DF1CB65-EF3A-49D4-AC6A-FCBE9419F126}"/>
               </a:ext>
             </a:extLst>
           </p:cNvPr>
@@ -3599,7 +3599,7 @@
           <p:cNvPr id="21" name="">
             <a:extLst xmlns:a="http://schemas.openxmlformats.org/drawingml/2006/main">
               <a:ext uri="{FF2B5EF4-FFF2-40B4-BE49-F238E27FC236}">
-                <a16:creationId xmlns:a16="http://schemas.microsoft.com/office/drawing/2014/main" id="{B73104B3-49FD-4C77-A2C1-45CB8199F8DA}"/>
+                <a16:creationId xmlns:a16="http://schemas.microsoft.com/office/drawing/2014/main" id="{15DC7B1A-52AD-4E72-BD44-1E4078429399}"/>
               </a:ext>
             </a:extLst>
           </p:cNvPr>
@@ -3647,7 +3647,7 @@
     </p:spTree>
     <p:extLst>
       <p:ext uri="{BB962C8B-B14F-4D97-AF65-F5344CB8AC3E}">
-        <p14:creationId xmlns:p14="http://schemas.microsoft.com/office/powerpoint/2010/main" val="662977577"/>
+        <p14:creationId xmlns:p14="http://schemas.microsoft.com/office/powerpoint/2010/main" val="1474150927"/>
       </p:ext>
     </p:extLst>
   </p:cSld>
@@ -3678,7 +3678,7 @@
           <p:cNvPr id="29" name="">
             <a:extLst xmlns:a="http://schemas.openxmlformats.org/drawingml/2006/main">
               <a:ext uri="{FF2B5EF4-FFF2-40B4-BE49-F238E27FC236}">
-                <a16:creationId xmlns:a16="http://schemas.microsoft.com/office/drawing/2014/main" id="{0154D3A3-4C3B-43A8-BCAD-8AEA30A45B2E}"/>
+                <a16:creationId xmlns:a16="http://schemas.microsoft.com/office/drawing/2014/main" id="{A26B1B45-3206-4C65-B8C7-66BAE4431584}"/>
               </a:ext>
             </a:extLst>
           </p:cNvPr>
@@ -3709,7 +3709,7 @@
           <p:cNvPr id="2" name="">
             <a:extLst xmlns:a="http://schemas.openxmlformats.org/drawingml/2006/main">
               <a:ext uri="{FF2B5EF4-FFF2-40B4-BE49-F238E27FC236}">
-                <a16:creationId xmlns:a16="http://schemas.microsoft.com/office/drawing/2014/main" id="{944C6D80-8D35-44B0-BC63-9DC12758876B}"/>
+                <a16:creationId xmlns:a16="http://schemas.microsoft.com/office/drawing/2014/main" id="{7D28365F-5E9B-43AF-9741-6053CB5E93A1}"/>
               </a:ext>
             </a:extLst>
           </p:cNvPr>
@@ -3759,7 +3759,7 @@
           <p:cNvPr id="3" name="">
             <a:extLst xmlns:a="http://schemas.openxmlformats.org/drawingml/2006/main">
               <a:ext uri="{FF2B5EF4-FFF2-40B4-BE49-F238E27FC236}">
-                <a16:creationId xmlns:a16="http://schemas.microsoft.com/office/drawing/2014/main" id="{F1AA3376-0E09-4D57-9B17-282D893F9E00}"/>
+                <a16:creationId xmlns:a16="http://schemas.microsoft.com/office/drawing/2014/main" id="{278A7F65-A66A-491C-A357-CB2CF2685263}"/>
               </a:ext>
             </a:extLst>
           </p:cNvPr>
@@ -3809,7 +3809,7 @@
           <p:cNvPr id="4" name="">
             <a:extLst xmlns:a="http://schemas.openxmlformats.org/drawingml/2006/main">
               <a:ext uri="{FF2B5EF4-FFF2-40B4-BE49-F238E27FC236}">
-                <a16:creationId xmlns:a16="http://schemas.microsoft.com/office/drawing/2014/main" id="{509C3E10-18A1-4B86-B934-C550220937C0}"/>
+                <a16:creationId xmlns:a16="http://schemas.microsoft.com/office/drawing/2014/main" id="{0F100AD1-7400-47F0-849F-2BEC5F3BAF5E}"/>
               </a:ext>
             </a:extLst>
           </p:cNvPr>
@@ -3840,7 +3840,7 @@
           <p:cNvPr id="5" name="">
             <a:extLst xmlns:a="http://schemas.openxmlformats.org/drawingml/2006/main">
               <a:ext uri="{FF2B5EF4-FFF2-40B4-BE49-F238E27FC236}">
-                <a16:creationId xmlns:a16="http://schemas.microsoft.com/office/drawing/2014/main" id="{CEBC81DF-BF2A-4E62-A324-C671831B46EE}"/>
+                <a16:creationId xmlns:a16="http://schemas.microsoft.com/office/drawing/2014/main" id="{A61CA078-4DF8-4445-A767-D2021F4936CC}"/>
               </a:ext>
             </a:extLst>
           </p:cNvPr>
@@ -3890,7 +3890,7 @@
           <p:cNvPr id="6" name="">
             <a:extLst xmlns:a="http://schemas.openxmlformats.org/drawingml/2006/main">
               <a:ext uri="{FF2B5EF4-FFF2-40B4-BE49-F238E27FC236}">
-                <a16:creationId xmlns:a16="http://schemas.microsoft.com/office/drawing/2014/main" id="{54AE137E-C63A-483C-9877-B0375E762729}"/>
+                <a16:creationId xmlns:a16="http://schemas.microsoft.com/office/drawing/2014/main" id="{258AD817-ED77-496B-A52D-62798BEFBEE8}"/>
               </a:ext>
             </a:extLst>
           </p:cNvPr>
@@ -3940,7 +3940,7 @@
           <p:cNvPr id="7" name="">
             <a:extLst xmlns:a="http://schemas.openxmlformats.org/drawingml/2006/main">
               <a:ext uri="{FF2B5EF4-FFF2-40B4-BE49-F238E27FC236}">
-                <a16:creationId xmlns:a16="http://schemas.microsoft.com/office/drawing/2014/main" id="{3475BF36-D8AB-4E2F-BDBA-CAB90CD0A306}"/>
+                <a16:creationId xmlns:a16="http://schemas.microsoft.com/office/drawing/2014/main" id="{2883B7A6-1D67-473C-955D-E67DBB4033DC}"/>
               </a:ext>
             </a:extLst>
           </p:cNvPr>
@@ -3973,7 +3973,7 @@
           <p:cNvPr id="8" name="">
             <a:extLst xmlns:a="http://schemas.openxmlformats.org/drawingml/2006/main">
               <a:ext uri="{FF2B5EF4-FFF2-40B4-BE49-F238E27FC236}">
-                <a16:creationId xmlns:a16="http://schemas.microsoft.com/office/drawing/2014/main" id="{22C33AF2-7CC3-4076-AC4A-59B8B3E744E4}"/>
+                <a16:creationId xmlns:a16="http://schemas.microsoft.com/office/drawing/2014/main" id="{5F25374B-F67A-425B-AF07-40025BAC7537}"/>
               </a:ext>
             </a:extLst>
           </p:cNvPr>
@@ -4023,7 +4023,7 @@
           <p:cNvPr id="9" name="">
             <a:extLst xmlns:a="http://schemas.openxmlformats.org/drawingml/2006/main">
               <a:ext uri="{FF2B5EF4-FFF2-40B4-BE49-F238E27FC236}">
-                <a16:creationId xmlns:a16="http://schemas.microsoft.com/office/drawing/2014/main" id="{AA8EF8DE-47E9-4B09-A800-3FC1AA65A2E0}"/>
+                <a16:creationId xmlns:a16="http://schemas.microsoft.com/office/drawing/2014/main" id="{CAEA6973-34EB-4503-8D48-4624C42A3BFF}"/>
               </a:ext>
             </a:extLst>
           </p:cNvPr>
@@ -4058,7 +4058,7 @@
           <p:cNvPr id="10" name="">
             <a:extLst xmlns:a="http://schemas.openxmlformats.org/drawingml/2006/main">
               <a:ext uri="{FF2B5EF4-FFF2-40B4-BE49-F238E27FC236}">
-                <a16:creationId xmlns:a16="http://schemas.microsoft.com/office/drawing/2014/main" id="{1B5EC493-A6DB-43E7-952C-F8EFA383ED35}"/>
+                <a16:creationId xmlns:a16="http://schemas.microsoft.com/office/drawing/2014/main" id="{87472B9A-598D-48C6-973D-747412B57977}"/>
               </a:ext>
             </a:extLst>
           </p:cNvPr>
@@ -4091,7 +4091,7 @@
           <p:cNvPr id="11" name="">
             <a:extLst xmlns:a="http://schemas.openxmlformats.org/drawingml/2006/main">
               <a:ext uri="{FF2B5EF4-FFF2-40B4-BE49-F238E27FC236}">
-                <a16:creationId xmlns:a16="http://schemas.microsoft.com/office/drawing/2014/main" id="{C5A51A1A-E794-4B8C-B5B9-DAE73237C0BA}"/>
+                <a16:creationId xmlns:a16="http://schemas.microsoft.com/office/drawing/2014/main" id="{4A0DE53B-E4E7-44E0-9456-E3BC55DEA2AD}"/>
               </a:ext>
             </a:extLst>
           </p:cNvPr>
@@ -4141,7 +4141,7 @@
           <p:cNvPr id="12" name="">
             <a:extLst xmlns:a="http://schemas.openxmlformats.org/drawingml/2006/main">
               <a:ext uri="{FF2B5EF4-FFF2-40B4-BE49-F238E27FC236}">
-                <a16:creationId xmlns:a16="http://schemas.microsoft.com/office/drawing/2014/main" id="{1A69DE50-1622-4762-8051-D4B490BD729D}"/>
+                <a16:creationId xmlns:a16="http://schemas.microsoft.com/office/drawing/2014/main" id="{8E51E34B-BBCC-4AA9-AF5F-557D9169F6C0}"/>
               </a:ext>
             </a:extLst>
           </p:cNvPr>
@@ -4242,7 +4242,7 @@
           <p:cNvPr id="13" name="">
             <a:extLst xmlns:a="http://schemas.openxmlformats.org/drawingml/2006/main">
               <a:ext uri="{FF2B5EF4-FFF2-40B4-BE49-F238E27FC236}">
-                <a16:creationId xmlns:a16="http://schemas.microsoft.com/office/drawing/2014/main" id="{E70C6D80-8B02-4933-B7CF-60D0825A2D3F}"/>
+                <a16:creationId xmlns:a16="http://schemas.microsoft.com/office/drawing/2014/main" id="{45D0DAE6-15D6-45DA-A020-4E13872DF3F9}"/>
               </a:ext>
             </a:extLst>
           </p:cNvPr>
@@ -4277,7 +4277,7 @@
           <p:cNvPr id="14" name="">
             <a:extLst xmlns:a="http://schemas.openxmlformats.org/drawingml/2006/main">
               <a:ext uri="{FF2B5EF4-FFF2-40B4-BE49-F238E27FC236}">
-                <a16:creationId xmlns:a16="http://schemas.microsoft.com/office/drawing/2014/main" id="{98DD2BAB-1038-4CE9-A31C-0171816E540F}"/>
+                <a16:creationId xmlns:a16="http://schemas.microsoft.com/office/drawing/2014/main" id="{4DD62440-0553-4226-8AC9-D2C7E926F858}"/>
               </a:ext>
             </a:extLst>
           </p:cNvPr>
@@ -4310,7 +4310,7 @@
           <p:cNvPr id="15" name="">
             <a:extLst xmlns:a="http://schemas.openxmlformats.org/drawingml/2006/main">
               <a:ext uri="{FF2B5EF4-FFF2-40B4-BE49-F238E27FC236}">
-                <a16:creationId xmlns:a16="http://schemas.microsoft.com/office/drawing/2014/main" id="{2CB9B8FE-8E3A-456E-9650-7D7EF4C863E6}"/>
+                <a16:creationId xmlns:a16="http://schemas.microsoft.com/office/drawing/2014/main" id="{89080213-2ADA-495D-937F-F60D5DD87E2F}"/>
               </a:ext>
             </a:extLst>
           </p:cNvPr>
@@ -4360,7 +4360,7 @@
           <p:cNvPr id="16" name="">
             <a:extLst xmlns:a="http://schemas.openxmlformats.org/drawingml/2006/main">
               <a:ext uri="{FF2B5EF4-FFF2-40B4-BE49-F238E27FC236}">
-                <a16:creationId xmlns:a16="http://schemas.microsoft.com/office/drawing/2014/main" id="{BA72694E-6DA8-472D-BDD4-A0E988B1FFA8}"/>
+                <a16:creationId xmlns:a16="http://schemas.microsoft.com/office/drawing/2014/main" id="{ADCBC5B5-2EC7-4E43-95E1-38B206C46215}"/>
               </a:ext>
             </a:extLst>
           </p:cNvPr>
@@ -4410,7 +4410,7 @@
           <p:cNvPr id="17" name="">
             <a:extLst xmlns:a="http://schemas.openxmlformats.org/drawingml/2006/main">
               <a:ext uri="{FF2B5EF4-FFF2-40B4-BE49-F238E27FC236}">
-                <a16:creationId xmlns:a16="http://schemas.microsoft.com/office/drawing/2014/main" id="{0EA78791-777F-47F7-9F91-A1C1D8FC3480}"/>
+                <a16:creationId xmlns:a16="http://schemas.microsoft.com/office/drawing/2014/main" id="{3FFC56E9-AAE8-4844-A7B1-DF20D982BEFA}"/>
               </a:ext>
             </a:extLst>
           </p:cNvPr>
@@ -4445,7 +4445,7 @@
           <p:cNvPr id="18" name="">
             <a:extLst xmlns:a="http://schemas.openxmlformats.org/drawingml/2006/main">
               <a:ext uri="{FF2B5EF4-FFF2-40B4-BE49-F238E27FC236}">
-                <a16:creationId xmlns:a16="http://schemas.microsoft.com/office/drawing/2014/main" id="{93D2D730-FCF2-4CC4-B6B8-BDDA5B873A52}"/>
+                <a16:creationId xmlns:a16="http://schemas.microsoft.com/office/drawing/2014/main" id="{FE9F5E8D-26E0-4F52-9115-6B5266A8F1C3}"/>
               </a:ext>
             </a:extLst>
           </p:cNvPr>
@@ -4478,7 +4478,7 @@
           <p:cNvPr id="19" name="">
             <a:extLst xmlns:a="http://schemas.openxmlformats.org/drawingml/2006/main">
               <a:ext uri="{FF2B5EF4-FFF2-40B4-BE49-F238E27FC236}">
-                <a16:creationId xmlns:a16="http://schemas.microsoft.com/office/drawing/2014/main" id="{60A227DF-BF18-41BE-BE37-3D20F8DE9AA8}"/>
+                <a16:creationId xmlns:a16="http://schemas.microsoft.com/office/drawing/2014/main" id="{49D8D707-BF25-41B6-9060-FA69B349A57F}"/>
               </a:ext>
             </a:extLst>
           </p:cNvPr>
@@ -4528,7 +4528,7 @@
           <p:cNvPr id="20" name="">
             <a:extLst xmlns:a="http://schemas.openxmlformats.org/drawingml/2006/main">
               <a:ext uri="{FF2B5EF4-FFF2-40B4-BE49-F238E27FC236}">
-                <a16:creationId xmlns:a16="http://schemas.microsoft.com/office/drawing/2014/main" id="{E434699B-F0F9-4958-954A-3C0BAA22CA87}"/>
+                <a16:creationId xmlns:a16="http://schemas.microsoft.com/office/drawing/2014/main" id="{D8DF854C-182D-4C22-BBBC-98904583051B}"/>
               </a:ext>
             </a:extLst>
           </p:cNvPr>
@@ -4681,7 +4681,7 @@
           <p:cNvPr id="23" name="">
             <a:extLst xmlns:a="http://schemas.openxmlformats.org/drawingml/2006/main">
               <a:ext uri="{FF2B5EF4-FFF2-40B4-BE49-F238E27FC236}">
-                <a16:creationId xmlns:a16="http://schemas.microsoft.com/office/drawing/2014/main" id="{E45E1683-527B-4612-9C47-F4753123FB64}"/>
+                <a16:creationId xmlns:a16="http://schemas.microsoft.com/office/drawing/2014/main" id="{D030C9B0-F41A-4973-B393-43304CACE8FD}"/>
               </a:ext>
             </a:extLst>
           </p:cNvPr>
@@ -4731,7 +4731,7 @@
           <p:cNvPr id="24" name="">
             <a:extLst xmlns:a="http://schemas.openxmlformats.org/drawingml/2006/main">
               <a:ext uri="{FF2B5EF4-FFF2-40B4-BE49-F238E27FC236}">
-                <a16:creationId xmlns:a16="http://schemas.microsoft.com/office/drawing/2014/main" id="{A56020A7-D9C1-4C03-8014-72653B4F7BEB}"/>
+                <a16:creationId xmlns:a16="http://schemas.microsoft.com/office/drawing/2014/main" id="{37BD638D-1277-4077-A891-B39F01157687}"/>
               </a:ext>
             </a:extLst>
           </p:cNvPr>
@@ -4781,7 +4781,7 @@
           <p:cNvPr id="25" name="">
             <a:extLst xmlns:a="http://schemas.openxmlformats.org/drawingml/2006/main">
               <a:ext uri="{FF2B5EF4-FFF2-40B4-BE49-F238E27FC236}">
-                <a16:creationId xmlns:a16="http://schemas.microsoft.com/office/drawing/2014/main" id="{2E03A472-E08B-4927-AA8F-6DD3B58FAEE2}"/>
+                <a16:creationId xmlns:a16="http://schemas.microsoft.com/office/drawing/2014/main" id="{98C28D09-9265-4F5D-AB71-C3326222445E}"/>
               </a:ext>
             </a:extLst>
           </p:cNvPr>
@@ -4812,7 +4812,7 @@
           <p:cNvPr id="26" name="">
             <a:extLst xmlns:a="http://schemas.openxmlformats.org/drawingml/2006/main">
               <a:ext uri="{FF2B5EF4-FFF2-40B4-BE49-F238E27FC236}">
-                <a16:creationId xmlns:a16="http://schemas.microsoft.com/office/drawing/2014/main" id="{B8A831D9-5DE6-4B60-B866-CB1B701D3E11}"/>
+                <a16:creationId xmlns:a16="http://schemas.microsoft.com/office/drawing/2014/main" id="{086C9775-4FBC-47B7-B761-8EE1720188B3}"/>
               </a:ext>
             </a:extLst>
           </p:cNvPr>
@@ -4843,7 +4843,7 @@
           <p:cNvPr id="27" name="">
             <a:extLst xmlns:a="http://schemas.openxmlformats.org/drawingml/2006/main">
               <a:ext uri="{FF2B5EF4-FFF2-40B4-BE49-F238E27FC236}">
-                <a16:creationId xmlns:a16="http://schemas.microsoft.com/office/drawing/2014/main" id="{15018DE2-25C6-4BB1-B5EF-E286F88A0E82}"/>
+                <a16:creationId xmlns:a16="http://schemas.microsoft.com/office/drawing/2014/main" id="{A3E39680-E11A-4F7F-B2D3-D8B8A470F340}"/>
               </a:ext>
             </a:extLst>
           </p:cNvPr>
@@ -4878,7 +4878,7 @@
           <p:cNvPr id="28" name="">
             <a:extLst xmlns:a="http://schemas.openxmlformats.org/drawingml/2006/main">
               <a:ext uri="{FF2B5EF4-FFF2-40B4-BE49-F238E27FC236}">
-                <a16:creationId xmlns:a16="http://schemas.microsoft.com/office/drawing/2014/main" id="{79E5D61B-C1FE-4F59-B803-9D80385C9D61}"/>
+                <a16:creationId xmlns:a16="http://schemas.microsoft.com/office/drawing/2014/main" id="{EE472EC3-FFA1-4E7E-8AE6-999AD2AB4FE8}"/>
               </a:ext>
             </a:extLst>
           </p:cNvPr>
@@ -4926,7 +4926,7 @@
     </p:spTree>
     <p:extLst>
       <p:ext uri="{BB962C8B-B14F-4D97-AF65-F5344CB8AC3E}">
-        <p14:creationId xmlns:p14="http://schemas.microsoft.com/office/powerpoint/2010/main" val="988785246"/>
+        <p14:creationId xmlns:p14="http://schemas.microsoft.com/office/powerpoint/2010/main" val="474817855"/>
       </p:ext>
     </p:extLst>
   </p:cSld>
@@ -4957,7 +4957,7 @@
           <p:cNvPr id="22" name="">
             <a:extLst xmlns:a="http://schemas.openxmlformats.org/drawingml/2006/main">
               <a:ext uri="{FF2B5EF4-FFF2-40B4-BE49-F238E27FC236}">
-                <a16:creationId xmlns:a16="http://schemas.microsoft.com/office/drawing/2014/main" id="{0E84E7DB-6BD0-4C2B-913E-F27062DB9A87}"/>
+                <a16:creationId xmlns:a16="http://schemas.microsoft.com/office/drawing/2014/main" id="{2EB1DF32-2A8E-417C-960A-9F98637345D1}"/>
               </a:ext>
             </a:extLst>
           </p:cNvPr>
@@ -4988,7 +4988,7 @@
           <p:cNvPr id="2" name="">
             <a:extLst xmlns:a="http://schemas.openxmlformats.org/drawingml/2006/main">
               <a:ext uri="{FF2B5EF4-FFF2-40B4-BE49-F238E27FC236}">
-                <a16:creationId xmlns:a16="http://schemas.microsoft.com/office/drawing/2014/main" id="{0357B8D8-9651-4872-B239-61A96C36E9F2}"/>
+                <a16:creationId xmlns:a16="http://schemas.microsoft.com/office/drawing/2014/main" id="{07D9BEDA-F8E8-4447-AAEF-35479646A2BE}"/>
               </a:ext>
             </a:extLst>
           </p:cNvPr>
@@ -5038,7 +5038,7 @@
           <p:cNvPr id="3" name="">
             <a:extLst xmlns:a="http://schemas.openxmlformats.org/drawingml/2006/main">
               <a:ext uri="{FF2B5EF4-FFF2-40B4-BE49-F238E27FC236}">
-                <a16:creationId xmlns:a16="http://schemas.microsoft.com/office/drawing/2014/main" id="{B5EB350A-6C36-439C-83D4-6EECE1375E78}"/>
+                <a16:creationId xmlns:a16="http://schemas.microsoft.com/office/drawing/2014/main" id="{F61D5270-E919-4EC6-8711-AF8E171C1D59}"/>
               </a:ext>
             </a:extLst>
           </p:cNvPr>
@@ -5088,7 +5088,7 @@
           <p:cNvPr id="4" name="">
             <a:extLst xmlns:a="http://schemas.openxmlformats.org/drawingml/2006/main">
               <a:ext uri="{FF2B5EF4-FFF2-40B4-BE49-F238E27FC236}">
-                <a16:creationId xmlns:a16="http://schemas.microsoft.com/office/drawing/2014/main" id="{A3577AFE-AAA0-42C9-B17C-D04A0750414D}"/>
+                <a16:creationId xmlns:a16="http://schemas.microsoft.com/office/drawing/2014/main" id="{CD4BEE3F-4136-46E4-9AD5-BCB00B0F3F4B}"/>
               </a:ext>
             </a:extLst>
           </p:cNvPr>
@@ -5119,7 +5119,7 @@
           <p:cNvPr id="5" name="">
             <a:extLst xmlns:a="http://schemas.openxmlformats.org/drawingml/2006/main">
               <a:ext uri="{FF2B5EF4-FFF2-40B4-BE49-F238E27FC236}">
-                <a16:creationId xmlns:a16="http://schemas.microsoft.com/office/drawing/2014/main" id="{3D3AB39A-21E2-4719-9588-4DA7419191EB}"/>
+                <a16:creationId xmlns:a16="http://schemas.microsoft.com/office/drawing/2014/main" id="{3E70C66D-C5CB-42CB-ACD3-C7226D481FFF}"/>
               </a:ext>
             </a:extLst>
           </p:cNvPr>
@@ -5169,7 +5169,7 @@
           <p:cNvPr id="6" name="">
             <a:extLst xmlns:a="http://schemas.openxmlformats.org/drawingml/2006/main">
               <a:ext uri="{FF2B5EF4-FFF2-40B4-BE49-F238E27FC236}">
-                <a16:creationId xmlns:a16="http://schemas.microsoft.com/office/drawing/2014/main" id="{57430DD7-89F3-4D33-9D12-9D2BA8DE8C6D}"/>
+                <a16:creationId xmlns:a16="http://schemas.microsoft.com/office/drawing/2014/main" id="{46BF6FC9-A9B1-40F5-8865-FDAF02824C51}"/>
               </a:ext>
             </a:extLst>
           </p:cNvPr>
@@ -5219,7 +5219,7 @@
           <p:cNvPr id="7" name="">
             <a:extLst xmlns:a="http://schemas.openxmlformats.org/drawingml/2006/main">
               <a:ext uri="{FF2B5EF4-FFF2-40B4-BE49-F238E27FC236}">
-                <a16:creationId xmlns:a16="http://schemas.microsoft.com/office/drawing/2014/main" id="{3D9FDF09-C907-4023-B389-0D1268752CD5}"/>
+                <a16:creationId xmlns:a16="http://schemas.microsoft.com/office/drawing/2014/main" id="{C5B8A7CA-5F69-4364-8158-970E0A80684F}"/>
               </a:ext>
             </a:extLst>
           </p:cNvPr>
@@ -5252,7 +5252,7 @@
           <p:cNvPr id="8" name="">
             <a:extLst xmlns:a="http://schemas.openxmlformats.org/drawingml/2006/main">
               <a:ext uri="{FF2B5EF4-FFF2-40B4-BE49-F238E27FC236}">
-                <a16:creationId xmlns:a16="http://schemas.microsoft.com/office/drawing/2014/main" id="{9E4E8284-4321-4D69-A7B9-913A64E426BD}"/>
+                <a16:creationId xmlns:a16="http://schemas.microsoft.com/office/drawing/2014/main" id="{DBE432EC-AEA1-46DC-A4A2-F6C887068BB1}"/>
               </a:ext>
             </a:extLst>
           </p:cNvPr>
@@ -5302,7 +5302,7 @@
           <p:cNvPr id="9" name="">
             <a:extLst xmlns:a="http://schemas.openxmlformats.org/drawingml/2006/main">
               <a:ext uri="{FF2B5EF4-FFF2-40B4-BE49-F238E27FC236}">
-                <a16:creationId xmlns:a16="http://schemas.microsoft.com/office/drawing/2014/main" id="{23E9441A-028C-4363-BB75-88669FF39190}"/>
+                <a16:creationId xmlns:a16="http://schemas.microsoft.com/office/drawing/2014/main" id="{51FCBEE7-E935-481B-9165-38FCACEE575A}"/>
               </a:ext>
             </a:extLst>
           </p:cNvPr>
@@ -5337,7 +5337,7 @@
           <p:cNvPr id="10" name="">
             <a:extLst xmlns:a="http://schemas.openxmlformats.org/drawingml/2006/main">
               <a:ext uri="{FF2B5EF4-FFF2-40B4-BE49-F238E27FC236}">
-                <a16:creationId xmlns:a16="http://schemas.microsoft.com/office/drawing/2014/main" id="{C592B6F2-1B73-4581-9162-1498362E1D88}"/>
+                <a16:creationId xmlns:a16="http://schemas.microsoft.com/office/drawing/2014/main" id="{B8852DFD-4AEA-4A22-8BCB-95D0AA98E449}"/>
               </a:ext>
             </a:extLst>
           </p:cNvPr>
@@ -5370,7 +5370,7 @@
           <p:cNvPr id="11" name="">
             <a:extLst xmlns:a="http://schemas.openxmlformats.org/drawingml/2006/main">
               <a:ext uri="{FF2B5EF4-FFF2-40B4-BE49-F238E27FC236}">
-                <a16:creationId xmlns:a16="http://schemas.microsoft.com/office/drawing/2014/main" id="{8765722D-73B0-41E7-9D04-7A93157D77E9}"/>
+                <a16:creationId xmlns:a16="http://schemas.microsoft.com/office/drawing/2014/main" id="{3BBAFCBE-D3AA-4110-B6A7-62EFE3E63082}"/>
               </a:ext>
             </a:extLst>
           </p:cNvPr>
@@ -5420,7 +5420,7 @@
           <p:cNvPr id="12" name="">
             <a:extLst xmlns:a="http://schemas.openxmlformats.org/drawingml/2006/main">
               <a:ext uri="{FF2B5EF4-FFF2-40B4-BE49-F238E27FC236}">
-                <a16:creationId xmlns:a16="http://schemas.microsoft.com/office/drawing/2014/main" id="{1F6AED78-3988-4DF4-9408-E8F191FB839C}"/>
+                <a16:creationId xmlns:a16="http://schemas.microsoft.com/office/drawing/2014/main" id="{A8543540-2775-4506-BC5F-19C4FA690AE7}"/>
               </a:ext>
             </a:extLst>
           </p:cNvPr>
@@ -5470,7 +5470,7 @@
           <p:cNvPr id="13" name="">
             <a:extLst xmlns:a="http://schemas.openxmlformats.org/drawingml/2006/main">
               <a:ext uri="{FF2B5EF4-FFF2-40B4-BE49-F238E27FC236}">
-                <a16:creationId xmlns:a16="http://schemas.microsoft.com/office/drawing/2014/main" id="{74168441-2B20-4074-8A1B-45E7E3D86F4C}"/>
+                <a16:creationId xmlns:a16="http://schemas.microsoft.com/office/drawing/2014/main" id="{8B1DB5F5-1048-4D4A-86D8-055D9092BB9E}"/>
               </a:ext>
             </a:extLst>
           </p:cNvPr>
@@ -5537,7 +5537,7 @@
           <p:cNvPr id="14" name="">
             <a:extLst xmlns:a="http://schemas.openxmlformats.org/drawingml/2006/main">
               <a:ext uri="{FF2B5EF4-FFF2-40B4-BE49-F238E27FC236}">
-                <a16:creationId xmlns:a16="http://schemas.microsoft.com/office/drawing/2014/main" id="{A645E759-DE98-4ADA-9091-4B3F94755A63}"/>
+                <a16:creationId xmlns:a16="http://schemas.microsoft.com/office/drawing/2014/main" id="{93574264-304B-440C-939F-F89195469DCD}"/>
               </a:ext>
             </a:extLst>
           </p:cNvPr>
@@ -5587,7 +5587,7 @@
           <p:cNvPr id="15" name="">
             <a:extLst xmlns:a="http://schemas.openxmlformats.org/drawingml/2006/main">
               <a:ext uri="{FF2B5EF4-FFF2-40B4-BE49-F238E27FC236}">
-                <a16:creationId xmlns:a16="http://schemas.microsoft.com/office/drawing/2014/main" id="{3B00EFC0-0E1B-439C-83D2-92AA22912806}"/>
+                <a16:creationId xmlns:a16="http://schemas.microsoft.com/office/drawing/2014/main" id="{AFF396DB-9E64-4941-AE3F-91DC5D79723A}"/>
               </a:ext>
             </a:extLst>
           </p:cNvPr>
@@ -5622,7 +5622,7 @@
           <p:cNvPr id="16" name="">
             <a:extLst xmlns:a="http://schemas.openxmlformats.org/drawingml/2006/main">
               <a:ext uri="{FF2B5EF4-FFF2-40B4-BE49-F238E27FC236}">
-                <a16:creationId xmlns:a16="http://schemas.microsoft.com/office/drawing/2014/main" id="{768144A0-3596-4A77-BE3A-07935EEDAD86}"/>
+                <a16:creationId xmlns:a16="http://schemas.microsoft.com/office/drawing/2014/main" id="{FC0C592D-1796-477B-84BA-B9668C0A0529}"/>
               </a:ext>
             </a:extLst>
           </p:cNvPr>
@@ -5655,7 +5655,7 @@
           <p:cNvPr id="17" name="">
             <a:extLst xmlns:a="http://schemas.openxmlformats.org/drawingml/2006/main">
               <a:ext uri="{FF2B5EF4-FFF2-40B4-BE49-F238E27FC236}">
-                <a16:creationId xmlns:a16="http://schemas.microsoft.com/office/drawing/2014/main" id="{B59AD97F-4493-416E-9CA9-68DB279EAD73}"/>
+                <a16:creationId xmlns:a16="http://schemas.microsoft.com/office/drawing/2014/main" id="{18D87A09-1C86-4A9D-A05D-25AC5F1DFA3B}"/>
               </a:ext>
             </a:extLst>
           </p:cNvPr>
@@ -5705,7 +5705,7 @@
           <p:cNvPr id="18" name="">
             <a:extLst xmlns:a="http://schemas.openxmlformats.org/drawingml/2006/main">
               <a:ext uri="{FF2B5EF4-FFF2-40B4-BE49-F238E27FC236}">
-                <a16:creationId xmlns:a16="http://schemas.microsoft.com/office/drawing/2014/main" id="{314AF6C3-8005-4EDF-9FF4-3398B8490FC0}"/>
+                <a16:creationId xmlns:a16="http://schemas.microsoft.com/office/drawing/2014/main" id="{E00FC9AA-26DA-4260-B1A1-29F5F545E5A2}"/>
               </a:ext>
             </a:extLst>
           </p:cNvPr>
@@ -5755,7 +5755,7 @@
           <p:cNvPr id="19" name="">
             <a:extLst xmlns:a="http://schemas.openxmlformats.org/drawingml/2006/main">
               <a:ext uri="{FF2B5EF4-FFF2-40B4-BE49-F238E27FC236}">
-                <a16:creationId xmlns:a16="http://schemas.microsoft.com/office/drawing/2014/main" id="{1D3FC994-D4E5-4B91-866A-0478BB5FB7FF}"/>
+                <a16:creationId xmlns:a16="http://schemas.microsoft.com/office/drawing/2014/main" id="{284D83EE-1771-4F72-B083-92E9DC624D53}"/>
               </a:ext>
             </a:extLst>
           </p:cNvPr>
@@ -5839,7 +5839,7 @@
           <p:cNvPr id="20" name="">
             <a:extLst xmlns:a="http://schemas.openxmlformats.org/drawingml/2006/main">
               <a:ext uri="{FF2B5EF4-FFF2-40B4-BE49-F238E27FC236}">
-                <a16:creationId xmlns:a16="http://schemas.microsoft.com/office/drawing/2014/main" id="{45918AC0-2DDA-470C-9E4F-1771C5629787}"/>
+                <a16:creationId xmlns:a16="http://schemas.microsoft.com/office/drawing/2014/main" id="{36FB15CB-0920-4EB5-8E3F-970A68786F9D}"/>
               </a:ext>
             </a:extLst>
           </p:cNvPr>
@@ -5889,7 +5889,7 @@
           <p:cNvPr id="21" name="">
             <a:extLst xmlns:a="http://schemas.openxmlformats.org/drawingml/2006/main">
               <a:ext uri="{FF2B5EF4-FFF2-40B4-BE49-F238E27FC236}">
-                <a16:creationId xmlns:a16="http://schemas.microsoft.com/office/drawing/2014/main" id="{E9404834-7C8F-4E19-8DC2-3BF62E557C58}"/>
+                <a16:creationId xmlns:a16="http://schemas.microsoft.com/office/drawing/2014/main" id="{856E01F6-3378-4FB9-81F3-880E15256940}"/>
               </a:ext>
             </a:extLst>
           </p:cNvPr>
@@ -5937,7 +5937,7 @@
     </p:spTree>
     <p:extLst>
       <p:ext uri="{BB962C8B-B14F-4D97-AF65-F5344CB8AC3E}">
-        <p14:creationId xmlns:p14="http://schemas.microsoft.com/office/powerpoint/2010/main" val="612949363"/>
+        <p14:creationId xmlns:p14="http://schemas.microsoft.com/office/powerpoint/2010/main" val="585086162"/>
       </p:ext>
     </p:extLst>
   </p:cSld>
@@ -5968,7 +5968,7 @@
           <p:cNvPr id="37" name="">
             <a:extLst xmlns:a="http://schemas.openxmlformats.org/drawingml/2006/main">
               <a:ext uri="{FF2B5EF4-FFF2-40B4-BE49-F238E27FC236}">
-                <a16:creationId xmlns:a16="http://schemas.microsoft.com/office/drawing/2014/main" id="{348A4FFB-E98A-40C3-85C2-4A20D07C34FC}"/>
+                <a16:creationId xmlns:a16="http://schemas.microsoft.com/office/drawing/2014/main" id="{B90A9282-5D32-4446-A6CE-D094648E7B9F}"/>
               </a:ext>
             </a:extLst>
           </p:cNvPr>
@@ -5999,7 +5999,7 @@
           <p:cNvPr id="2" name="">
             <a:extLst xmlns:a="http://schemas.openxmlformats.org/drawingml/2006/main">
               <a:ext uri="{FF2B5EF4-FFF2-40B4-BE49-F238E27FC236}">
-                <a16:creationId xmlns:a16="http://schemas.microsoft.com/office/drawing/2014/main" id="{AF07FB4F-312D-4617-A333-5378C4886AC4}"/>
+                <a16:creationId xmlns:a16="http://schemas.microsoft.com/office/drawing/2014/main" id="{939123A8-9545-4D20-BCB9-07FE6282CF18}"/>
               </a:ext>
             </a:extLst>
           </p:cNvPr>
@@ -6049,7 +6049,7 @@
           <p:cNvPr id="3" name="">
             <a:extLst xmlns:a="http://schemas.openxmlformats.org/drawingml/2006/main">
               <a:ext uri="{FF2B5EF4-FFF2-40B4-BE49-F238E27FC236}">
-                <a16:creationId xmlns:a16="http://schemas.microsoft.com/office/drawing/2014/main" id="{1460FE74-4CD7-4D68-A1E0-C53D879E1CD2}"/>
+                <a16:creationId xmlns:a16="http://schemas.microsoft.com/office/drawing/2014/main" id="{79DBF128-ABFD-4BE8-B9E8-1E7217551E28}"/>
               </a:ext>
             </a:extLst>
           </p:cNvPr>
@@ -6099,7 +6099,7 @@
           <p:cNvPr id="4" name="">
             <a:extLst xmlns:a="http://schemas.openxmlformats.org/drawingml/2006/main">
               <a:ext uri="{FF2B5EF4-FFF2-40B4-BE49-F238E27FC236}">
-                <a16:creationId xmlns:a16="http://schemas.microsoft.com/office/drawing/2014/main" id="{7C9130C8-1041-41BE-806F-63DC0857EB41}"/>
+                <a16:creationId xmlns:a16="http://schemas.microsoft.com/office/drawing/2014/main" id="{0515FE41-4CCD-4C5F-B810-D3922149C689}"/>
               </a:ext>
             </a:extLst>
           </p:cNvPr>
@@ -6130,7 +6130,7 @@
           <p:cNvPr id="5" name="">
             <a:extLst xmlns:a="http://schemas.openxmlformats.org/drawingml/2006/main">
               <a:ext uri="{FF2B5EF4-FFF2-40B4-BE49-F238E27FC236}">
-                <a16:creationId xmlns:a16="http://schemas.microsoft.com/office/drawing/2014/main" id="{7E4359CB-B942-45EA-ADD2-EEE9F4484EF3}"/>
+                <a16:creationId xmlns:a16="http://schemas.microsoft.com/office/drawing/2014/main" id="{5921209F-1752-49BB-86F7-6610074A6AA9}"/>
               </a:ext>
             </a:extLst>
           </p:cNvPr>
@@ -6180,7 +6180,7 @@
           <p:cNvPr id="6" name="">
             <a:extLst xmlns:a="http://schemas.openxmlformats.org/drawingml/2006/main">
               <a:ext uri="{FF2B5EF4-FFF2-40B4-BE49-F238E27FC236}">
-                <a16:creationId xmlns:a16="http://schemas.microsoft.com/office/drawing/2014/main" id="{0876650C-0E2C-4C9A-AB5B-D5EB2CB180D6}"/>
+                <a16:creationId xmlns:a16="http://schemas.microsoft.com/office/drawing/2014/main" id="{2A1AFDE4-530F-4790-94AC-11CF546B772A}"/>
               </a:ext>
             </a:extLst>
           </p:cNvPr>
@@ -6230,7 +6230,7 @@
           <p:cNvPr id="7" name="">
             <a:extLst xmlns:a="http://schemas.openxmlformats.org/drawingml/2006/main">
               <a:ext uri="{FF2B5EF4-FFF2-40B4-BE49-F238E27FC236}">
-                <a16:creationId xmlns:a16="http://schemas.microsoft.com/office/drawing/2014/main" id="{DA2C21DD-77BB-4AB1-B011-21A5057F3A3C}"/>
+                <a16:creationId xmlns:a16="http://schemas.microsoft.com/office/drawing/2014/main" id="{CC14BEC3-92AD-4F55-AF31-BC1698C6ECF3}"/>
               </a:ext>
             </a:extLst>
           </p:cNvPr>
@@ -6263,7 +6263,7 @@
           <p:cNvPr id="8" name="">
             <a:extLst xmlns:a="http://schemas.openxmlformats.org/drawingml/2006/main">
               <a:ext uri="{FF2B5EF4-FFF2-40B4-BE49-F238E27FC236}">
-                <a16:creationId xmlns:a16="http://schemas.microsoft.com/office/drawing/2014/main" id="{4609FB01-D9B1-430E-ABAF-E4E136394D78}"/>
+                <a16:creationId xmlns:a16="http://schemas.microsoft.com/office/drawing/2014/main" id="{E315A00F-8E73-4281-B24B-F23AD71C5381}"/>
               </a:ext>
             </a:extLst>
           </p:cNvPr>
@@ -6313,7 +6313,7 @@
           <p:cNvPr id="9" name="">
             <a:extLst xmlns:a="http://schemas.openxmlformats.org/drawingml/2006/main">
               <a:ext uri="{FF2B5EF4-FFF2-40B4-BE49-F238E27FC236}">
-                <a16:creationId xmlns:a16="http://schemas.microsoft.com/office/drawing/2014/main" id="{C2E8ED7E-1E1A-4865-8ADC-E49BF4AD9790}"/>
+                <a16:creationId xmlns:a16="http://schemas.microsoft.com/office/drawing/2014/main" id="{4B5BA2F5-A5B5-4790-81A5-151857A2B00F}"/>
               </a:ext>
             </a:extLst>
           </p:cNvPr>
@@ -6348,7 +6348,7 @@
           <p:cNvPr id="10" name="">
             <a:extLst xmlns:a="http://schemas.openxmlformats.org/drawingml/2006/main">
               <a:ext uri="{FF2B5EF4-FFF2-40B4-BE49-F238E27FC236}">
-                <a16:creationId xmlns:a16="http://schemas.microsoft.com/office/drawing/2014/main" id="{DF0D45A1-40D0-48CE-8BD8-8271C456075C}"/>
+                <a16:creationId xmlns:a16="http://schemas.microsoft.com/office/drawing/2014/main" id="{9C7AAF63-4B72-4D9F-86BB-1C6A3763C8ED}"/>
               </a:ext>
             </a:extLst>
           </p:cNvPr>
@@ -6381,7 +6381,7 @@
           <p:cNvPr id="11" name="">
             <a:extLst xmlns:a="http://schemas.openxmlformats.org/drawingml/2006/main">
               <a:ext uri="{FF2B5EF4-FFF2-40B4-BE49-F238E27FC236}">
-                <a16:creationId xmlns:a16="http://schemas.microsoft.com/office/drawing/2014/main" id="{1D0DDC8A-1DCA-4931-97AC-E9E0771CC301}"/>
+                <a16:creationId xmlns:a16="http://schemas.microsoft.com/office/drawing/2014/main" id="{C224CA7E-4AC1-4F4C-84D8-9D9294FE4CFF}"/>
               </a:ext>
             </a:extLst>
           </p:cNvPr>
@@ -6431,7 +6431,7 @@
           <p:cNvPr id="12" name="">
             <a:extLst xmlns:a="http://schemas.openxmlformats.org/drawingml/2006/main">
               <a:ext uri="{FF2B5EF4-FFF2-40B4-BE49-F238E27FC236}">
-                <a16:creationId xmlns:a16="http://schemas.microsoft.com/office/drawing/2014/main" id="{C2E49BD4-3F76-41E2-A7C0-080C99451654}"/>
+                <a16:creationId xmlns:a16="http://schemas.microsoft.com/office/drawing/2014/main" id="{F31AD261-1BAD-4262-9FB8-B13EF6A1774E}"/>
               </a:ext>
             </a:extLst>
           </p:cNvPr>
@@ -6481,7 +6481,7 @@
           <p:cNvPr id="13" name="">
             <a:extLst xmlns:a="http://schemas.openxmlformats.org/drawingml/2006/main">
               <a:ext uri="{FF2B5EF4-FFF2-40B4-BE49-F238E27FC236}">
-                <a16:creationId xmlns:a16="http://schemas.microsoft.com/office/drawing/2014/main" id="{08B1676D-34E4-4479-B2BC-7AFE2A7A3B5A}"/>
+                <a16:creationId xmlns:a16="http://schemas.microsoft.com/office/drawing/2014/main" id="{B4B27B16-B01F-4A87-B244-42658D53B302}"/>
               </a:ext>
             </a:extLst>
           </p:cNvPr>
@@ -6516,7 +6516,7 @@
           <p:cNvPr id="14" name="">
             <a:extLst xmlns:a="http://schemas.openxmlformats.org/drawingml/2006/main">
               <a:ext uri="{FF2B5EF4-FFF2-40B4-BE49-F238E27FC236}">
-                <a16:creationId xmlns:a16="http://schemas.microsoft.com/office/drawing/2014/main" id="{D5480141-0A99-4FB4-A1D5-DB5C9CE1F32B}"/>
+                <a16:creationId xmlns:a16="http://schemas.microsoft.com/office/drawing/2014/main" id="{9F0172E8-1518-4C38-973E-E66BE76A5FBC}"/>
               </a:ext>
             </a:extLst>
           </p:cNvPr>
@@ -6549,7 +6549,7 @@
           <p:cNvPr id="15" name="">
             <a:extLst xmlns:a="http://schemas.openxmlformats.org/drawingml/2006/main">
               <a:ext uri="{FF2B5EF4-FFF2-40B4-BE49-F238E27FC236}">
-                <a16:creationId xmlns:a16="http://schemas.microsoft.com/office/drawing/2014/main" id="{3EE46695-72B9-4CB1-906D-80C9BEA640C7}"/>
+                <a16:creationId xmlns:a16="http://schemas.microsoft.com/office/drawing/2014/main" id="{8D9CA66E-3CF3-4B02-A796-5D988151CF70}"/>
               </a:ext>
             </a:extLst>
           </p:cNvPr>
@@ -6599,7 +6599,7 @@
           <p:cNvPr id="16" name="">
             <a:extLst xmlns:a="http://schemas.openxmlformats.org/drawingml/2006/main">
               <a:ext uri="{FF2B5EF4-FFF2-40B4-BE49-F238E27FC236}">
-                <a16:creationId xmlns:a16="http://schemas.microsoft.com/office/drawing/2014/main" id="{0804DD7B-A85A-4437-B0E3-8F0A1CC2774A}"/>
+                <a16:creationId xmlns:a16="http://schemas.microsoft.com/office/drawing/2014/main" id="{FE93EA57-BCBF-4824-AE0C-2F4BD4D7DF78}"/>
               </a:ext>
             </a:extLst>
           </p:cNvPr>
@@ -6649,7 +6649,7 @@
           <p:cNvPr id="17" name="">
             <a:extLst xmlns:a="http://schemas.openxmlformats.org/drawingml/2006/main">
               <a:ext uri="{FF2B5EF4-FFF2-40B4-BE49-F238E27FC236}">
-                <a16:creationId xmlns:a16="http://schemas.microsoft.com/office/drawing/2014/main" id="{F4EFD2C7-A1A6-4B46-ADC0-24704B81D114}"/>
+                <a16:creationId xmlns:a16="http://schemas.microsoft.com/office/drawing/2014/main" id="{2F6DB4EC-4AB0-491F-A8C8-51874A879D23}"/>
               </a:ext>
             </a:extLst>
           </p:cNvPr>
@@ -6684,7 +6684,7 @@
           <p:cNvPr id="18" name="">
             <a:extLst xmlns:a="http://schemas.openxmlformats.org/drawingml/2006/main">
               <a:ext uri="{FF2B5EF4-FFF2-40B4-BE49-F238E27FC236}">
-                <a16:creationId xmlns:a16="http://schemas.microsoft.com/office/drawing/2014/main" id="{27EED4E8-E60E-4C2F-8ADF-DD3101E46096}"/>
+                <a16:creationId xmlns:a16="http://schemas.microsoft.com/office/drawing/2014/main" id="{38401EB1-7E65-4361-93ED-8CDC8E7AEAEC}"/>
               </a:ext>
             </a:extLst>
           </p:cNvPr>
@@ -6717,7 +6717,7 @@
           <p:cNvPr id="19" name="">
             <a:extLst xmlns:a="http://schemas.openxmlformats.org/drawingml/2006/main">
               <a:ext uri="{FF2B5EF4-FFF2-40B4-BE49-F238E27FC236}">
-                <a16:creationId xmlns:a16="http://schemas.microsoft.com/office/drawing/2014/main" id="{A2C877C5-E085-4ED9-9FC6-B4107D1A77E7}"/>
+                <a16:creationId xmlns:a16="http://schemas.microsoft.com/office/drawing/2014/main" id="{9968B40E-0C4C-40A3-BD6D-1F7D66D92B88}"/>
               </a:ext>
             </a:extLst>
           </p:cNvPr>
@@ -6767,7 +6767,7 @@
           <p:cNvPr id="20" name="">
             <a:extLst xmlns:a="http://schemas.openxmlformats.org/drawingml/2006/main">
               <a:ext uri="{FF2B5EF4-FFF2-40B4-BE49-F238E27FC236}">
-                <a16:creationId xmlns:a16="http://schemas.microsoft.com/office/drawing/2014/main" id="{206E2490-EDFC-4A06-A7EB-9045FA69B327}"/>
+                <a16:creationId xmlns:a16="http://schemas.microsoft.com/office/drawing/2014/main" id="{03103DEE-E351-4738-BBA6-F6D7E420C767}"/>
               </a:ext>
             </a:extLst>
           </p:cNvPr>
@@ -6869,7 +6869,7 @@
           <p:cNvPr id="23" name="">
             <a:extLst xmlns:a="http://schemas.openxmlformats.org/drawingml/2006/main">
               <a:ext uri="{FF2B5EF4-FFF2-40B4-BE49-F238E27FC236}">
-                <a16:creationId xmlns:a16="http://schemas.microsoft.com/office/drawing/2014/main" id="{33E824BF-F165-4A01-9F56-25AAC303FF53}"/>
+                <a16:creationId xmlns:a16="http://schemas.microsoft.com/office/drawing/2014/main" id="{65976DBB-35D7-4249-AC47-25BDDA3D4994}"/>
               </a:ext>
             </a:extLst>
           </p:cNvPr>
@@ -6904,7 +6904,7 @@
           <p:cNvPr id="24" name="">
             <a:extLst xmlns:a="http://schemas.openxmlformats.org/drawingml/2006/main">
               <a:ext uri="{FF2B5EF4-FFF2-40B4-BE49-F238E27FC236}">
-                <a16:creationId xmlns:a16="http://schemas.microsoft.com/office/drawing/2014/main" id="{612BDF01-6BEE-402D-8A5D-B147F6AF1E37}"/>
+                <a16:creationId xmlns:a16="http://schemas.microsoft.com/office/drawing/2014/main" id="{EAAE9D6B-07E1-4904-B7B8-D037363F4549}"/>
               </a:ext>
             </a:extLst>
           </p:cNvPr>
@@ -6937,7 +6937,7 @@
           <p:cNvPr id="25" name="">
             <a:extLst xmlns:a="http://schemas.openxmlformats.org/drawingml/2006/main">
               <a:ext uri="{FF2B5EF4-FFF2-40B4-BE49-F238E27FC236}">
-                <a16:creationId xmlns:a16="http://schemas.microsoft.com/office/drawing/2014/main" id="{94AB7CA7-133A-4AA7-9967-F195A26B6B2C}"/>
+                <a16:creationId xmlns:a16="http://schemas.microsoft.com/office/drawing/2014/main" id="{5156FBE5-A774-4278-A248-A7E8A500A597}"/>
               </a:ext>
             </a:extLst>
           </p:cNvPr>
@@ -6987,7 +6987,7 @@
           <p:cNvPr id="26" name="">
             <a:extLst xmlns:a="http://schemas.openxmlformats.org/drawingml/2006/main">
               <a:ext uri="{FF2B5EF4-FFF2-40B4-BE49-F238E27FC236}">
-                <a16:creationId xmlns:a16="http://schemas.microsoft.com/office/drawing/2014/main" id="{25F8CC2A-643C-4EAF-98A1-7037360C3A76}"/>
+                <a16:creationId xmlns:a16="http://schemas.microsoft.com/office/drawing/2014/main" id="{0FC4B713-3EB0-4040-B25D-71DBB0BAF4A6}"/>
               </a:ext>
             </a:extLst>
           </p:cNvPr>
@@ -7063,7 +7063,7 @@
           <p:cNvPr id="28" name="">
             <a:extLst xmlns:a="http://schemas.openxmlformats.org/drawingml/2006/main">
               <a:ext uri="{FF2B5EF4-FFF2-40B4-BE49-F238E27FC236}">
-                <a16:creationId xmlns:a16="http://schemas.microsoft.com/office/drawing/2014/main" id="{93CAF8F5-FF90-422C-82C6-F14024CE867D}"/>
+                <a16:creationId xmlns:a16="http://schemas.microsoft.com/office/drawing/2014/main" id="{89DC6ED5-87D8-4F92-BD4E-AC69EB9E902A}"/>
               </a:ext>
             </a:extLst>
           </p:cNvPr>
@@ -7098,7 +7098,7 @@
           <p:cNvPr id="29" name="">
             <a:extLst xmlns:a="http://schemas.openxmlformats.org/drawingml/2006/main">
               <a:ext uri="{FF2B5EF4-FFF2-40B4-BE49-F238E27FC236}">
-                <a16:creationId xmlns:a16="http://schemas.microsoft.com/office/drawing/2014/main" id="{E215E666-353C-4AAD-8C5D-A56F55BD9F67}"/>
+                <a16:creationId xmlns:a16="http://schemas.microsoft.com/office/drawing/2014/main" id="{8ADB705B-6642-472F-B791-1B9203B7568C}"/>
               </a:ext>
             </a:extLst>
           </p:cNvPr>
@@ -7148,7 +7148,7 @@
           <p:cNvPr id="30" name="">
             <a:extLst xmlns:a="http://schemas.openxmlformats.org/drawingml/2006/main">
               <a:ext uri="{FF2B5EF4-FFF2-40B4-BE49-F238E27FC236}">
-                <a16:creationId xmlns:a16="http://schemas.microsoft.com/office/drawing/2014/main" id="{957AA4ED-C8EC-44ED-8A88-230E2707BFB6}"/>
+                <a16:creationId xmlns:a16="http://schemas.microsoft.com/office/drawing/2014/main" id="{6FA647B0-14C7-4E32-97AC-5E3C72FD0803}"/>
               </a:ext>
             </a:extLst>
           </p:cNvPr>
@@ -7198,7 +7198,7 @@
           <p:cNvPr id="31" name="">
             <a:extLst xmlns:a="http://schemas.openxmlformats.org/drawingml/2006/main">
               <a:ext uri="{FF2B5EF4-FFF2-40B4-BE49-F238E27FC236}">
-                <a16:creationId xmlns:a16="http://schemas.microsoft.com/office/drawing/2014/main" id="{A7F7A51C-EAD9-4E7B-B291-4A0CB058D088}"/>
+                <a16:creationId xmlns:a16="http://schemas.microsoft.com/office/drawing/2014/main" id="{E2CE4AF9-5D3C-483D-84FC-DC63FD059DD5}"/>
               </a:ext>
             </a:extLst>
           </p:cNvPr>
@@ -7233,7 +7233,7 @@
           <p:cNvPr id="32" name="">
             <a:extLst xmlns:a="http://schemas.openxmlformats.org/drawingml/2006/main">
               <a:ext uri="{FF2B5EF4-FFF2-40B4-BE49-F238E27FC236}">
-                <a16:creationId xmlns:a16="http://schemas.microsoft.com/office/drawing/2014/main" id="{8FC01605-FE6B-4D23-9A8D-785FAC43118B}"/>
+                <a16:creationId xmlns:a16="http://schemas.microsoft.com/office/drawing/2014/main" id="{8284C20B-EDD7-47C9-85C4-1C2FBB5A8F1D}"/>
               </a:ext>
             </a:extLst>
           </p:cNvPr>
@@ -7283,7 +7283,7 @@
           <p:cNvPr id="33" name="">
             <a:extLst xmlns:a="http://schemas.openxmlformats.org/drawingml/2006/main">
               <a:ext uri="{FF2B5EF4-FFF2-40B4-BE49-F238E27FC236}">
-                <a16:creationId xmlns:a16="http://schemas.microsoft.com/office/drawing/2014/main" id="{AA20D4FC-9F9B-4E65-86F4-D685718531CF}"/>
+                <a16:creationId xmlns:a16="http://schemas.microsoft.com/office/drawing/2014/main" id="{FFAAA9AF-FCDE-4A97-8A02-AFC9A73B1ED7}"/>
               </a:ext>
             </a:extLst>
           </p:cNvPr>
@@ -7333,7 +7333,7 @@
           <p:cNvPr id="34" name="">
             <a:extLst xmlns:a="http://schemas.openxmlformats.org/drawingml/2006/main">
               <a:ext uri="{FF2B5EF4-FFF2-40B4-BE49-F238E27FC236}">
-                <a16:creationId xmlns:a16="http://schemas.microsoft.com/office/drawing/2014/main" id="{065B14CE-A081-4938-B64A-B248E1C697A0}"/>
+                <a16:creationId xmlns:a16="http://schemas.microsoft.com/office/drawing/2014/main" id="{5C641777-B1AB-474E-A44D-021452A1F270}"/>
               </a:ext>
             </a:extLst>
           </p:cNvPr>
@@ -7368,7 +7368,7 @@
           <p:cNvPr id="35" name="">
             <a:extLst xmlns:a="http://schemas.openxmlformats.org/drawingml/2006/main">
               <a:ext uri="{FF2B5EF4-FFF2-40B4-BE49-F238E27FC236}">
-                <a16:creationId xmlns:a16="http://schemas.microsoft.com/office/drawing/2014/main" id="{061F7FAC-1A20-4C00-9265-E3DE9E3EC166}"/>
+                <a16:creationId xmlns:a16="http://schemas.microsoft.com/office/drawing/2014/main" id="{30D9E34C-C8AE-4D0A-A6BB-196CE34BEFD8}"/>
               </a:ext>
             </a:extLst>
           </p:cNvPr>
@@ -7418,7 +7418,7 @@
           <p:cNvPr id="36" name="">
             <a:extLst xmlns:a="http://schemas.openxmlformats.org/drawingml/2006/main">
               <a:ext uri="{FF2B5EF4-FFF2-40B4-BE49-F238E27FC236}">
-                <a16:creationId xmlns:a16="http://schemas.microsoft.com/office/drawing/2014/main" id="{B942F075-0551-4178-9FE8-E627E1F72BFB}"/>
+                <a16:creationId xmlns:a16="http://schemas.microsoft.com/office/drawing/2014/main" id="{F10D5AEB-234D-4365-ACFC-F366D38F51AD}"/>
               </a:ext>
             </a:extLst>
           </p:cNvPr>
@@ -7466,7 +7466,7 @@
     </p:spTree>
     <p:extLst>
       <p:ext uri="{BB962C8B-B14F-4D97-AF65-F5344CB8AC3E}">
-        <p14:creationId xmlns:p14="http://schemas.microsoft.com/office/powerpoint/2010/main" val="894181973"/>
+        <p14:creationId xmlns:p14="http://schemas.microsoft.com/office/powerpoint/2010/main" val="1151107315"/>
       </p:ext>
     </p:extLst>
   </p:cSld>
@@ -7497,7 +7497,7 @@
           <p:cNvPr id="41" name="">
             <a:extLst xmlns:a="http://schemas.openxmlformats.org/drawingml/2006/main">
               <a:ext uri="{FF2B5EF4-FFF2-40B4-BE49-F238E27FC236}">
-                <a16:creationId xmlns:a16="http://schemas.microsoft.com/office/drawing/2014/main" id="{332BF719-32DD-4794-A974-07C5EB423D62}"/>
+                <a16:creationId xmlns:a16="http://schemas.microsoft.com/office/drawing/2014/main" id="{B99A66ED-AE2C-4516-8223-26CB8ECA92B5}"/>
               </a:ext>
             </a:extLst>
           </p:cNvPr>
@@ -7528,7 +7528,7 @@
           <p:cNvPr id="2" name="">
             <a:extLst xmlns:a="http://schemas.openxmlformats.org/drawingml/2006/main">
               <a:ext uri="{FF2B5EF4-FFF2-40B4-BE49-F238E27FC236}">
-                <a16:creationId xmlns:a16="http://schemas.microsoft.com/office/drawing/2014/main" id="{57D96007-75AD-4A38-97A9-3FA5A308710D}"/>
+                <a16:creationId xmlns:a16="http://schemas.microsoft.com/office/drawing/2014/main" id="{7F185B68-2DFA-4654-8540-603728EDDA45}"/>
               </a:ext>
             </a:extLst>
           </p:cNvPr>
@@ -7578,7 +7578,7 @@
           <p:cNvPr id="3" name="">
             <a:extLst xmlns:a="http://schemas.openxmlformats.org/drawingml/2006/main">
               <a:ext uri="{FF2B5EF4-FFF2-40B4-BE49-F238E27FC236}">
-                <a16:creationId xmlns:a16="http://schemas.microsoft.com/office/drawing/2014/main" id="{79C9908D-18D5-41CF-8767-9F8116C2EF4C}"/>
+                <a16:creationId xmlns:a16="http://schemas.microsoft.com/office/drawing/2014/main" id="{0F09B50F-A5C9-4FE0-85FD-F8AF302DE9D6}"/>
               </a:ext>
             </a:extLst>
           </p:cNvPr>
@@ -7628,7 +7628,7 @@
           <p:cNvPr id="4" name="">
             <a:extLst xmlns:a="http://schemas.openxmlformats.org/drawingml/2006/main">
               <a:ext uri="{FF2B5EF4-FFF2-40B4-BE49-F238E27FC236}">
-                <a16:creationId xmlns:a16="http://schemas.microsoft.com/office/drawing/2014/main" id="{2D005951-374F-4643-A27C-368B35394B8D}"/>
+                <a16:creationId xmlns:a16="http://schemas.microsoft.com/office/drawing/2014/main" id="{9468DFB6-73E5-44D6-96F5-63CAE79BE0B2}"/>
               </a:ext>
             </a:extLst>
           </p:cNvPr>
@@ -7659,7 +7659,7 @@
           <p:cNvPr id="5" name="">
             <a:extLst xmlns:a="http://schemas.openxmlformats.org/drawingml/2006/main">
               <a:ext uri="{FF2B5EF4-FFF2-40B4-BE49-F238E27FC236}">
-                <a16:creationId xmlns:a16="http://schemas.microsoft.com/office/drawing/2014/main" id="{DF618B97-3D83-4F7E-BE98-84DFF4A02229}"/>
+                <a16:creationId xmlns:a16="http://schemas.microsoft.com/office/drawing/2014/main" id="{CF75313A-D9C9-497A-B5FC-9125C8ADB989}"/>
               </a:ext>
             </a:extLst>
           </p:cNvPr>
@@ -7709,7 +7709,7 @@
           <p:cNvPr id="6" name="">
             <a:extLst xmlns:a="http://schemas.openxmlformats.org/drawingml/2006/main">
               <a:ext uri="{FF2B5EF4-FFF2-40B4-BE49-F238E27FC236}">
-                <a16:creationId xmlns:a16="http://schemas.microsoft.com/office/drawing/2014/main" id="{6BB4234A-45F0-4966-B898-4F65FADA9821}"/>
+                <a16:creationId xmlns:a16="http://schemas.microsoft.com/office/drawing/2014/main" id="{6BB0883A-662B-484A-AB5B-690B5C7BD14F}"/>
               </a:ext>
             </a:extLst>
           </p:cNvPr>
@@ -7759,7 +7759,7 @@
           <p:cNvPr id="7" name="">
             <a:extLst xmlns:a="http://schemas.openxmlformats.org/drawingml/2006/main">
               <a:ext uri="{FF2B5EF4-FFF2-40B4-BE49-F238E27FC236}">
-                <a16:creationId xmlns:a16="http://schemas.microsoft.com/office/drawing/2014/main" id="{F725E12D-D827-465C-8875-0B2D4C6874BC}"/>
+                <a16:creationId xmlns:a16="http://schemas.microsoft.com/office/drawing/2014/main" id="{38EE1B13-7D45-4DF2-B96F-0AA79996DB7C}"/>
               </a:ext>
             </a:extLst>
           </p:cNvPr>
@@ -7792,7 +7792,7 @@
           <p:cNvPr id="8" name="">
             <a:extLst xmlns:a="http://schemas.openxmlformats.org/drawingml/2006/main">
               <a:ext uri="{FF2B5EF4-FFF2-40B4-BE49-F238E27FC236}">
-                <a16:creationId xmlns:a16="http://schemas.microsoft.com/office/drawing/2014/main" id="{33E2B066-5886-4A02-BDD9-2932DB79366A}"/>
+                <a16:creationId xmlns:a16="http://schemas.microsoft.com/office/drawing/2014/main" id="{29BEFF00-1F96-4FD4-8619-32DF279BA121}"/>
               </a:ext>
             </a:extLst>
           </p:cNvPr>
@@ -7842,7 +7842,7 @@
           <p:cNvPr id="9" name="">
             <a:extLst xmlns:a="http://schemas.openxmlformats.org/drawingml/2006/main">
               <a:ext uri="{FF2B5EF4-FFF2-40B4-BE49-F238E27FC236}">
-                <a16:creationId xmlns:a16="http://schemas.microsoft.com/office/drawing/2014/main" id="{FF1DD023-B8C9-44F3-AAC6-80A0335EF4F9}"/>
+                <a16:creationId xmlns:a16="http://schemas.microsoft.com/office/drawing/2014/main" id="{E343E1EC-81C1-4B8F-832A-ADDD5D9DE6F6}"/>
               </a:ext>
             </a:extLst>
           </p:cNvPr>
@@ -7877,7 +7877,7 @@
           <p:cNvPr id="10" name="">
             <a:extLst xmlns:a="http://schemas.openxmlformats.org/drawingml/2006/main">
               <a:ext uri="{FF2B5EF4-FFF2-40B4-BE49-F238E27FC236}">
-                <a16:creationId xmlns:a16="http://schemas.microsoft.com/office/drawing/2014/main" id="{3F73BC24-C4AE-4DD1-A999-40A86EE4BD7D}"/>
+                <a16:creationId xmlns:a16="http://schemas.microsoft.com/office/drawing/2014/main" id="{ABD96C2C-B87E-4DD2-8FE6-B0799EBFE1EB}"/>
               </a:ext>
             </a:extLst>
           </p:cNvPr>
@@ -7910,7 +7910,7 @@
           <p:cNvPr id="11" name="">
             <a:extLst xmlns:a="http://schemas.openxmlformats.org/drawingml/2006/main">
               <a:ext uri="{FF2B5EF4-FFF2-40B4-BE49-F238E27FC236}">
-                <a16:creationId xmlns:a16="http://schemas.microsoft.com/office/drawing/2014/main" id="{CC5F5C44-9DB5-4749-87EC-DFFAD551E25F}"/>
+                <a16:creationId xmlns:a16="http://schemas.microsoft.com/office/drawing/2014/main" id="{D6FB4F70-8AF9-428C-BA57-A29412FB6BE9}"/>
               </a:ext>
             </a:extLst>
           </p:cNvPr>
@@ -7960,7 +7960,7 @@
           <p:cNvPr id="12" name="">
             <a:extLst xmlns:a="http://schemas.openxmlformats.org/drawingml/2006/main">
               <a:ext uri="{FF2B5EF4-FFF2-40B4-BE49-F238E27FC236}">
-                <a16:creationId xmlns:a16="http://schemas.microsoft.com/office/drawing/2014/main" id="{76307530-1ABB-4DBF-A0E8-6256FE26BE99}"/>
+                <a16:creationId xmlns:a16="http://schemas.microsoft.com/office/drawing/2014/main" id="{82648334-45F3-450B-A22F-968451187B50}"/>
               </a:ext>
             </a:extLst>
           </p:cNvPr>
@@ -8010,7 +8010,7 @@
           <p:cNvPr id="13" name="">
             <a:extLst xmlns:a="http://schemas.openxmlformats.org/drawingml/2006/main">
               <a:ext uri="{FF2B5EF4-FFF2-40B4-BE49-F238E27FC236}">
-                <a16:creationId xmlns:a16="http://schemas.microsoft.com/office/drawing/2014/main" id="{E810AF5B-5C9A-4B77-BB0A-6EF0B552DA8C}"/>
+                <a16:creationId xmlns:a16="http://schemas.microsoft.com/office/drawing/2014/main" id="{8FE690A0-E3D0-44F5-A6CD-449DF71F082B}"/>
               </a:ext>
             </a:extLst>
           </p:cNvPr>
@@ -8045,7 +8045,7 @@
           <p:cNvPr id="14" name="">
             <a:extLst xmlns:a="http://schemas.openxmlformats.org/drawingml/2006/main">
               <a:ext uri="{FF2B5EF4-FFF2-40B4-BE49-F238E27FC236}">
-                <a16:creationId xmlns:a16="http://schemas.microsoft.com/office/drawing/2014/main" id="{18CD06B1-55D2-463A-B0E2-100DC28429E8}"/>
+                <a16:creationId xmlns:a16="http://schemas.microsoft.com/office/drawing/2014/main" id="{1F29F047-3B3E-47C5-A76E-33BDD6A25E16}"/>
               </a:ext>
             </a:extLst>
           </p:cNvPr>
@@ -8078,7 +8078,7 @@
           <p:cNvPr id="15" name="">
             <a:extLst xmlns:a="http://schemas.openxmlformats.org/drawingml/2006/main">
               <a:ext uri="{FF2B5EF4-FFF2-40B4-BE49-F238E27FC236}">
-                <a16:creationId xmlns:a16="http://schemas.microsoft.com/office/drawing/2014/main" id="{7123BABD-CE4E-4E0D-9A4C-6EEEBE4D7416}"/>
+                <a16:creationId xmlns:a16="http://schemas.microsoft.com/office/drawing/2014/main" id="{D9B6BAA1-6F42-4604-BBBA-C4EA8533AF4C}"/>
               </a:ext>
             </a:extLst>
           </p:cNvPr>
@@ -8128,7 +8128,7 @@
           <p:cNvPr id="16" name="">
             <a:extLst xmlns:a="http://schemas.openxmlformats.org/drawingml/2006/main">
               <a:ext uri="{FF2B5EF4-FFF2-40B4-BE49-F238E27FC236}">
-                <a16:creationId xmlns:a16="http://schemas.microsoft.com/office/drawing/2014/main" id="{58392A17-2685-4B8E-8FA9-B91998137170}"/>
+                <a16:creationId xmlns:a16="http://schemas.microsoft.com/office/drawing/2014/main" id="{31C5F4FC-C895-40CB-BE9A-C7B0D0E07ABA}"/>
               </a:ext>
             </a:extLst>
           </p:cNvPr>
@@ -8178,7 +8178,7 @@
           <p:cNvPr id="17" name="">
             <a:extLst xmlns:a="http://schemas.openxmlformats.org/drawingml/2006/main">
               <a:ext uri="{FF2B5EF4-FFF2-40B4-BE49-F238E27FC236}">
-                <a16:creationId xmlns:a16="http://schemas.microsoft.com/office/drawing/2014/main" id="{884B7E09-A139-4787-AFE5-A2922BE0E28C}"/>
+                <a16:creationId xmlns:a16="http://schemas.microsoft.com/office/drawing/2014/main" id="{71135BD4-0070-48BC-890A-7189FAF8A01F}"/>
               </a:ext>
             </a:extLst>
           </p:cNvPr>
@@ -8213,7 +8213,7 @@
           <p:cNvPr id="18" name="">
             <a:extLst xmlns:a="http://schemas.openxmlformats.org/drawingml/2006/main">
               <a:ext uri="{FF2B5EF4-FFF2-40B4-BE49-F238E27FC236}">
-                <a16:creationId xmlns:a16="http://schemas.microsoft.com/office/drawing/2014/main" id="{D6B370E0-F114-4EB7-8A16-1745745F9D20}"/>
+                <a16:creationId xmlns:a16="http://schemas.microsoft.com/office/drawing/2014/main" id="{12FE57D0-98E2-493C-B454-ED4D8A6A0C2A}"/>
               </a:ext>
             </a:extLst>
           </p:cNvPr>
@@ -8246,7 +8246,7 @@
           <p:cNvPr id="19" name="">
             <a:extLst xmlns:a="http://schemas.openxmlformats.org/drawingml/2006/main">
               <a:ext uri="{FF2B5EF4-FFF2-40B4-BE49-F238E27FC236}">
-                <a16:creationId xmlns:a16="http://schemas.microsoft.com/office/drawing/2014/main" id="{023A9758-A622-446C-8851-073A36A91B2F}"/>
+                <a16:creationId xmlns:a16="http://schemas.microsoft.com/office/drawing/2014/main" id="{7B229886-6FC5-42FD-A914-151713A0B16A}"/>
               </a:ext>
             </a:extLst>
           </p:cNvPr>
@@ -8296,7 +8296,7 @@
           <p:cNvPr id="20" name="">
             <a:extLst xmlns:a="http://schemas.openxmlformats.org/drawingml/2006/main">
               <a:ext uri="{FF2B5EF4-FFF2-40B4-BE49-F238E27FC236}">
-                <a16:creationId xmlns:a16="http://schemas.microsoft.com/office/drawing/2014/main" id="{644FC3BB-97D5-4CB8-B161-93C756E1C990}"/>
+                <a16:creationId xmlns:a16="http://schemas.microsoft.com/office/drawing/2014/main" id="{740993DA-FE7B-413F-910B-569DFAF741ED}"/>
               </a:ext>
             </a:extLst>
           </p:cNvPr>
@@ -8346,7 +8346,7 @@
           <p:cNvPr id="21" name="">
             <a:extLst xmlns:a="http://schemas.openxmlformats.org/drawingml/2006/main">
               <a:ext uri="{FF2B5EF4-FFF2-40B4-BE49-F238E27FC236}">
-                <a16:creationId xmlns:a16="http://schemas.microsoft.com/office/drawing/2014/main" id="{8FECC6D7-8DBD-4C11-8C9D-F4C6D050566F}"/>
+                <a16:creationId xmlns:a16="http://schemas.microsoft.com/office/drawing/2014/main" id="{DC5734A9-DDA2-482F-88AE-A362964B1FC7}"/>
               </a:ext>
             </a:extLst>
           </p:cNvPr>
@@ -8381,7 +8381,7 @@
           <p:cNvPr id="22" name="">
             <a:extLst xmlns:a="http://schemas.openxmlformats.org/drawingml/2006/main">
               <a:ext uri="{FF2B5EF4-FFF2-40B4-BE49-F238E27FC236}">
-                <a16:creationId xmlns:a16="http://schemas.microsoft.com/office/drawing/2014/main" id="{949CE84C-C639-4F66-BF8E-066DC8F1D57E}"/>
+                <a16:creationId xmlns:a16="http://schemas.microsoft.com/office/drawing/2014/main" id="{148FCDA3-5659-48A6-B625-5C810B4AECB8}"/>
               </a:ext>
             </a:extLst>
           </p:cNvPr>
@@ -8414,7 +8414,7 @@
           <p:cNvPr id="23" name="">
             <a:extLst xmlns:a="http://schemas.openxmlformats.org/drawingml/2006/main">
               <a:ext uri="{FF2B5EF4-FFF2-40B4-BE49-F238E27FC236}">
-                <a16:creationId xmlns:a16="http://schemas.microsoft.com/office/drawing/2014/main" id="{F041DD5F-7B48-4184-BD76-8EAD9C6A6A36}"/>
+                <a16:creationId xmlns:a16="http://schemas.microsoft.com/office/drawing/2014/main" id="{0BA790F7-2255-40EC-B370-747C4B34F81E}"/>
               </a:ext>
             </a:extLst>
           </p:cNvPr>
@@ -8464,7 +8464,7 @@
           <p:cNvPr id="24" name="">
             <a:extLst xmlns:a="http://schemas.openxmlformats.org/drawingml/2006/main">
               <a:ext uri="{FF2B5EF4-FFF2-40B4-BE49-F238E27FC236}">
-                <a16:creationId xmlns:a16="http://schemas.microsoft.com/office/drawing/2014/main" id="{89DA2B54-9CA9-47E9-A127-22367732081D}"/>
+                <a16:creationId xmlns:a16="http://schemas.microsoft.com/office/drawing/2014/main" id="{73C84C41-E713-4DD8-B4E9-F34AACB992DC}"/>
               </a:ext>
             </a:extLst>
           </p:cNvPr>
@@ -8592,7 +8592,7 @@
           <p:cNvPr id="28" name="">
             <a:extLst xmlns:a="http://schemas.openxmlformats.org/drawingml/2006/main">
               <a:ext uri="{FF2B5EF4-FFF2-40B4-BE49-F238E27FC236}">
-                <a16:creationId xmlns:a16="http://schemas.microsoft.com/office/drawing/2014/main" id="{011E8E10-F198-4AE8-BD6D-80E0F5C3E9A7}"/>
+                <a16:creationId xmlns:a16="http://schemas.microsoft.com/office/drawing/2014/main" id="{8B205FB8-D14C-4CBD-9BA3-C6EA20175158}"/>
               </a:ext>
             </a:extLst>
           </p:cNvPr>
@@ -8627,7 +8627,7 @@
           <p:cNvPr id="29" name="">
             <a:extLst xmlns:a="http://schemas.openxmlformats.org/drawingml/2006/main">
               <a:ext uri="{FF2B5EF4-FFF2-40B4-BE49-F238E27FC236}">
-                <a16:creationId xmlns:a16="http://schemas.microsoft.com/office/drawing/2014/main" id="{EE206FA5-D1A4-497E-AAF5-49B8E6075748}"/>
+                <a16:creationId xmlns:a16="http://schemas.microsoft.com/office/drawing/2014/main" id="{1F468604-E997-481B-8700-301224EC45AD}"/>
               </a:ext>
             </a:extLst>
           </p:cNvPr>
@@ -8660,7 +8660,7 @@
           <p:cNvPr id="30" name="">
             <a:extLst xmlns:a="http://schemas.openxmlformats.org/drawingml/2006/main">
               <a:ext uri="{FF2B5EF4-FFF2-40B4-BE49-F238E27FC236}">
-                <a16:creationId xmlns:a16="http://schemas.microsoft.com/office/drawing/2014/main" id="{2E250A58-D737-4DC4-877E-BC5B1E8A8387}"/>
+                <a16:creationId xmlns:a16="http://schemas.microsoft.com/office/drawing/2014/main" id="{71E862D0-3AE8-4270-BF9B-3DAE496D9DC3}"/>
               </a:ext>
             </a:extLst>
           </p:cNvPr>
@@ -8710,7 +8710,7 @@
           <p:cNvPr id="31" name="">
             <a:extLst xmlns:a="http://schemas.openxmlformats.org/drawingml/2006/main">
               <a:ext uri="{FF2B5EF4-FFF2-40B4-BE49-F238E27FC236}">
-                <a16:creationId xmlns:a16="http://schemas.microsoft.com/office/drawing/2014/main" id="{828C918C-1816-4228-A1CE-E01A47329362}"/>
+                <a16:creationId xmlns:a16="http://schemas.microsoft.com/office/drawing/2014/main" id="{4D89E18E-9DA4-4E2A-9F65-06C892B38788}"/>
               </a:ext>
             </a:extLst>
           </p:cNvPr>
@@ -8786,7 +8786,7 @@
           <p:cNvPr id="33" name="">
             <a:extLst xmlns:a="http://schemas.openxmlformats.org/drawingml/2006/main">
               <a:ext uri="{FF2B5EF4-FFF2-40B4-BE49-F238E27FC236}">
-                <a16:creationId xmlns:a16="http://schemas.microsoft.com/office/drawing/2014/main" id="{77122126-B3CF-4B1C-AF40-8093DA7FC9FE}"/>
+                <a16:creationId xmlns:a16="http://schemas.microsoft.com/office/drawing/2014/main" id="{4FC891B0-B4D2-4736-8465-7FC3748250F6}"/>
               </a:ext>
             </a:extLst>
           </p:cNvPr>
@@ -8821,7 +8821,7 @@
           <p:cNvPr id="34" name="">
             <a:extLst xmlns:a="http://schemas.openxmlformats.org/drawingml/2006/main">
               <a:ext uri="{FF2B5EF4-FFF2-40B4-BE49-F238E27FC236}">
-                <a16:creationId xmlns:a16="http://schemas.microsoft.com/office/drawing/2014/main" id="{145F1380-0724-496D-8831-3F7D1621BC39}"/>
+                <a16:creationId xmlns:a16="http://schemas.microsoft.com/office/drawing/2014/main" id="{5A6CDE59-974B-401A-B002-E4376C515A34}"/>
               </a:ext>
             </a:extLst>
           </p:cNvPr>
@@ -8854,7 +8854,7 @@
           <p:cNvPr id="35" name="">
             <a:extLst xmlns:a="http://schemas.openxmlformats.org/drawingml/2006/main">
               <a:ext uri="{FF2B5EF4-FFF2-40B4-BE49-F238E27FC236}">
-                <a16:creationId xmlns:a16="http://schemas.microsoft.com/office/drawing/2014/main" id="{72525D9B-E09B-4AB7-A11B-9C93D071D1A8}"/>
+                <a16:creationId xmlns:a16="http://schemas.microsoft.com/office/drawing/2014/main" id="{7BC198CB-8980-4B8D-95FF-9668A26A1322}"/>
               </a:ext>
             </a:extLst>
           </p:cNvPr>
@@ -8904,7 +8904,7 @@
           <p:cNvPr id="36" name="">
             <a:extLst xmlns:a="http://schemas.openxmlformats.org/drawingml/2006/main">
               <a:ext uri="{FF2B5EF4-FFF2-40B4-BE49-F238E27FC236}">
-                <a16:creationId xmlns:a16="http://schemas.microsoft.com/office/drawing/2014/main" id="{33D61E9D-E7F2-4A35-9A60-FA98DB0A18DC}"/>
+                <a16:creationId xmlns:a16="http://schemas.microsoft.com/office/drawing/2014/main" id="{8787BF22-69DC-4A98-AE5A-74DF58A27979}"/>
               </a:ext>
             </a:extLst>
           </p:cNvPr>
@@ -8980,7 +8980,7 @@
           <p:cNvPr id="38" name="">
             <a:extLst xmlns:a="http://schemas.openxmlformats.org/drawingml/2006/main">
               <a:ext uri="{FF2B5EF4-FFF2-40B4-BE49-F238E27FC236}">
-                <a16:creationId xmlns:a16="http://schemas.microsoft.com/office/drawing/2014/main" id="{B3B3078F-38CD-4A68-A6B7-8571C11F0583}"/>
+                <a16:creationId xmlns:a16="http://schemas.microsoft.com/office/drawing/2014/main" id="{F273F8BB-4A37-4100-B1AF-211E530112A1}"/>
               </a:ext>
             </a:extLst>
           </p:cNvPr>
@@ -9030,7 +9030,7 @@
           <p:cNvPr id="39" name="">
             <a:extLst xmlns:a="http://schemas.openxmlformats.org/drawingml/2006/main">
               <a:ext uri="{FF2B5EF4-FFF2-40B4-BE49-F238E27FC236}">
-                <a16:creationId xmlns:a16="http://schemas.microsoft.com/office/drawing/2014/main" id="{92A205AF-A908-404F-91BA-1261CC12C5E1}"/>
+                <a16:creationId xmlns:a16="http://schemas.microsoft.com/office/drawing/2014/main" id="{B7552BA9-220E-4734-81ED-3FB2809FF1BA}"/>
               </a:ext>
             </a:extLst>
           </p:cNvPr>
@@ -9114,7 +9114,7 @@
           <p:cNvPr id="40" name="">
             <a:extLst xmlns:a="http://schemas.openxmlformats.org/drawingml/2006/main">
               <a:ext uri="{FF2B5EF4-FFF2-40B4-BE49-F238E27FC236}">
-                <a16:creationId xmlns:a16="http://schemas.microsoft.com/office/drawing/2014/main" id="{FE629109-ECFC-442A-B6F1-DE5B8D8D2DF6}"/>
+                <a16:creationId xmlns:a16="http://schemas.microsoft.com/office/drawing/2014/main" id="{A18A6C21-00CF-427D-A8C9-CECEA181B851}"/>
               </a:ext>
             </a:extLst>
           </p:cNvPr>
@@ -9162,7 +9162,7 @@
     </p:spTree>
     <p:extLst>
       <p:ext uri="{BB962C8B-B14F-4D97-AF65-F5344CB8AC3E}">
-        <p14:creationId xmlns:p14="http://schemas.microsoft.com/office/powerpoint/2010/main" val="2044993231"/>
+        <p14:creationId xmlns:p14="http://schemas.microsoft.com/office/powerpoint/2010/main" val="332516074"/>
       </p:ext>
     </p:extLst>
   </p:cSld>
@@ -9193,7 +9193,7 @@
           <p:cNvPr id="35" name="">
             <a:extLst xmlns:a="http://schemas.openxmlformats.org/drawingml/2006/main">
               <a:ext uri="{FF2B5EF4-FFF2-40B4-BE49-F238E27FC236}">
-                <a16:creationId xmlns:a16="http://schemas.microsoft.com/office/drawing/2014/main" id="{74C63156-8787-443B-BEE6-6D25618AA4A9}"/>
+                <a16:creationId xmlns:a16="http://schemas.microsoft.com/office/drawing/2014/main" id="{47A91E86-2481-4CE0-886D-FBAE2B8E6846}"/>
               </a:ext>
             </a:extLst>
           </p:cNvPr>
@@ -9224,7 +9224,7 @@
           <p:cNvPr id="2" name="">
             <a:extLst xmlns:a="http://schemas.openxmlformats.org/drawingml/2006/main">
               <a:ext uri="{FF2B5EF4-FFF2-40B4-BE49-F238E27FC236}">
-                <a16:creationId xmlns:a16="http://schemas.microsoft.com/office/drawing/2014/main" id="{71CF3163-7E3F-47DD-96FB-4FC9F3141F58}"/>
+                <a16:creationId xmlns:a16="http://schemas.microsoft.com/office/drawing/2014/main" id="{BFFD15B0-C4B8-418D-8C98-0374F2F5BF2A}"/>
               </a:ext>
             </a:extLst>
           </p:cNvPr>
@@ -9274,7 +9274,7 @@
           <p:cNvPr id="3" name="">
             <a:extLst xmlns:a="http://schemas.openxmlformats.org/drawingml/2006/main">
               <a:ext uri="{FF2B5EF4-FFF2-40B4-BE49-F238E27FC236}">
-                <a16:creationId xmlns:a16="http://schemas.microsoft.com/office/drawing/2014/main" id="{B204D8CF-8A19-487A-931A-A0216F5DB61E}"/>
+                <a16:creationId xmlns:a16="http://schemas.microsoft.com/office/drawing/2014/main" id="{4FD79DDF-9C93-48E7-81AC-460752DDCA15}"/>
               </a:ext>
             </a:extLst>
           </p:cNvPr>
@@ -9324,7 +9324,7 @@
           <p:cNvPr id="4" name="">
             <a:extLst xmlns:a="http://schemas.openxmlformats.org/drawingml/2006/main">
               <a:ext uri="{FF2B5EF4-FFF2-40B4-BE49-F238E27FC236}">
-                <a16:creationId xmlns:a16="http://schemas.microsoft.com/office/drawing/2014/main" id="{9E8A44A5-A306-49DA-8570-50A900BE5220}"/>
+                <a16:creationId xmlns:a16="http://schemas.microsoft.com/office/drawing/2014/main" id="{6561FB10-26E8-47A8-B830-160584AAA068}"/>
               </a:ext>
             </a:extLst>
           </p:cNvPr>
@@ -9355,7 +9355,7 @@
           <p:cNvPr id="5" name="">
             <a:extLst xmlns:a="http://schemas.openxmlformats.org/drawingml/2006/main">
               <a:ext uri="{FF2B5EF4-FFF2-40B4-BE49-F238E27FC236}">
-                <a16:creationId xmlns:a16="http://schemas.microsoft.com/office/drawing/2014/main" id="{B4BEAD25-5442-4BDB-9783-9F881B5A69D9}"/>
+                <a16:creationId xmlns:a16="http://schemas.microsoft.com/office/drawing/2014/main" id="{59351D38-321D-4502-9B0A-DEEBF86FFF92}"/>
               </a:ext>
             </a:extLst>
           </p:cNvPr>
@@ -9405,7 +9405,7 @@
           <p:cNvPr id="6" name="">
             <a:extLst xmlns:a="http://schemas.openxmlformats.org/drawingml/2006/main">
               <a:ext uri="{FF2B5EF4-FFF2-40B4-BE49-F238E27FC236}">
-                <a16:creationId xmlns:a16="http://schemas.microsoft.com/office/drawing/2014/main" id="{17A49B16-48C9-4633-BDB2-A09CEF83AF75}"/>
+                <a16:creationId xmlns:a16="http://schemas.microsoft.com/office/drawing/2014/main" id="{C79BFAB8-AD3D-4A78-9431-226D97F15A7A}"/>
               </a:ext>
             </a:extLst>
           </p:cNvPr>
@@ -9455,7 +9455,7 @@
           <p:cNvPr id="7" name="">
             <a:extLst xmlns:a="http://schemas.openxmlformats.org/drawingml/2006/main">
               <a:ext uri="{FF2B5EF4-FFF2-40B4-BE49-F238E27FC236}">
-                <a16:creationId xmlns:a16="http://schemas.microsoft.com/office/drawing/2014/main" id="{47CA512C-7100-40B6-9CA5-E99499010663}"/>
+                <a16:creationId xmlns:a16="http://schemas.microsoft.com/office/drawing/2014/main" id="{9D4508DF-D5F0-497E-A420-0572BAF2EE4F}"/>
               </a:ext>
             </a:extLst>
           </p:cNvPr>
@@ -9488,7 +9488,7 @@
           <p:cNvPr id="8" name="">
             <a:extLst xmlns:a="http://schemas.openxmlformats.org/drawingml/2006/main">
               <a:ext uri="{FF2B5EF4-FFF2-40B4-BE49-F238E27FC236}">
-                <a16:creationId xmlns:a16="http://schemas.microsoft.com/office/drawing/2014/main" id="{1C00617C-8BC0-47A6-B596-B56F7A35B9D8}"/>
+                <a16:creationId xmlns:a16="http://schemas.microsoft.com/office/drawing/2014/main" id="{B023CDF8-D21F-4B8B-B539-81F0108D5907}"/>
               </a:ext>
             </a:extLst>
           </p:cNvPr>
@@ -9538,7 +9538,7 @@
           <p:cNvPr id="9" name="">
             <a:extLst xmlns:a="http://schemas.openxmlformats.org/drawingml/2006/main">
               <a:ext uri="{FF2B5EF4-FFF2-40B4-BE49-F238E27FC236}">
-                <a16:creationId xmlns:a16="http://schemas.microsoft.com/office/drawing/2014/main" id="{280F5E96-3FB0-4A6D-B4E1-94B85311F078}"/>
+                <a16:creationId xmlns:a16="http://schemas.microsoft.com/office/drawing/2014/main" id="{DC84CEC7-89D6-4D71-9EF6-96BA9269738C}"/>
               </a:ext>
             </a:extLst>
           </p:cNvPr>
@@ -9573,7 +9573,7 @@
           <p:cNvPr id="10" name="">
             <a:extLst xmlns:a="http://schemas.openxmlformats.org/drawingml/2006/main">
               <a:ext uri="{FF2B5EF4-FFF2-40B4-BE49-F238E27FC236}">
-                <a16:creationId xmlns:a16="http://schemas.microsoft.com/office/drawing/2014/main" id="{6D4423EA-EB6A-4D70-B437-18205664EAE2}"/>
+                <a16:creationId xmlns:a16="http://schemas.microsoft.com/office/drawing/2014/main" id="{857E9280-5556-417A-BFFF-05EEC299B78E}"/>
               </a:ext>
             </a:extLst>
           </p:cNvPr>
@@ -9606,7 +9606,7 @@
           <p:cNvPr id="11" name="">
             <a:extLst xmlns:a="http://schemas.openxmlformats.org/drawingml/2006/main">
               <a:ext uri="{FF2B5EF4-FFF2-40B4-BE49-F238E27FC236}">
-                <a16:creationId xmlns:a16="http://schemas.microsoft.com/office/drawing/2014/main" id="{FE672863-D47E-4E37-8F51-B37F651DFB25}"/>
+                <a16:creationId xmlns:a16="http://schemas.microsoft.com/office/drawing/2014/main" id="{93F175B5-0C87-46A3-B5F5-9B1898B0C98D}"/>
               </a:ext>
             </a:extLst>
           </p:cNvPr>
@@ -9656,7 +9656,7 @@
           <p:cNvPr id="12" name="">
             <a:extLst xmlns:a="http://schemas.openxmlformats.org/drawingml/2006/main">
               <a:ext uri="{FF2B5EF4-FFF2-40B4-BE49-F238E27FC236}">
-                <a16:creationId xmlns:a16="http://schemas.microsoft.com/office/drawing/2014/main" id="{8D66ECF2-0FAE-4DEC-8A3B-1CCD9FDE7583}"/>
+                <a16:creationId xmlns:a16="http://schemas.microsoft.com/office/drawing/2014/main" id="{319670FA-E8F9-481C-B2B5-F5F8CCF4D5D0}"/>
               </a:ext>
             </a:extLst>
           </p:cNvPr>
@@ -9706,7 +9706,7 @@
           <p:cNvPr id="13" name="">
             <a:extLst xmlns:a="http://schemas.openxmlformats.org/drawingml/2006/main">
               <a:ext uri="{FF2B5EF4-FFF2-40B4-BE49-F238E27FC236}">
-                <a16:creationId xmlns:a16="http://schemas.microsoft.com/office/drawing/2014/main" id="{3E0C222B-6E5E-4B84-AD1C-E10D53151238}"/>
+                <a16:creationId xmlns:a16="http://schemas.microsoft.com/office/drawing/2014/main" id="{66561719-41D8-4670-9855-8F19DCB6C58E}"/>
               </a:ext>
             </a:extLst>
           </p:cNvPr>
@@ -9741,7 +9741,7 @@
           <p:cNvPr id="14" name="">
             <a:extLst xmlns:a="http://schemas.openxmlformats.org/drawingml/2006/main">
               <a:ext uri="{FF2B5EF4-FFF2-40B4-BE49-F238E27FC236}">
-                <a16:creationId xmlns:a16="http://schemas.microsoft.com/office/drawing/2014/main" id="{3584AADF-3857-47AF-BA2F-171910E89971}"/>
+                <a16:creationId xmlns:a16="http://schemas.microsoft.com/office/drawing/2014/main" id="{273B86D7-F94D-4823-9345-AE118D672455}"/>
               </a:ext>
             </a:extLst>
           </p:cNvPr>
@@ -9774,7 +9774,7 @@
           <p:cNvPr id="15" name="">
             <a:extLst xmlns:a="http://schemas.openxmlformats.org/drawingml/2006/main">
               <a:ext uri="{FF2B5EF4-FFF2-40B4-BE49-F238E27FC236}">
-                <a16:creationId xmlns:a16="http://schemas.microsoft.com/office/drawing/2014/main" id="{3C59858C-C5AB-4698-BC8A-6613D7E9832A}"/>
+                <a16:creationId xmlns:a16="http://schemas.microsoft.com/office/drawing/2014/main" id="{17EDCE36-0D17-4204-889D-ED501EB39CB6}"/>
               </a:ext>
             </a:extLst>
           </p:cNvPr>
@@ -9824,7 +9824,7 @@
           <p:cNvPr id="16" name="">
             <a:extLst xmlns:a="http://schemas.openxmlformats.org/drawingml/2006/main">
               <a:ext uri="{FF2B5EF4-FFF2-40B4-BE49-F238E27FC236}">
-                <a16:creationId xmlns:a16="http://schemas.microsoft.com/office/drawing/2014/main" id="{65BCCB21-241F-4193-ABBB-713C12A2D5DD}"/>
+                <a16:creationId xmlns:a16="http://schemas.microsoft.com/office/drawing/2014/main" id="{065CE56E-E361-47C2-AC36-6548AE73EA3A}"/>
               </a:ext>
             </a:extLst>
           </p:cNvPr>
@@ -9874,7 +9874,7 @@
           <p:cNvPr id="17" name="">
             <a:extLst xmlns:a="http://schemas.openxmlformats.org/drawingml/2006/main">
               <a:ext uri="{FF2B5EF4-FFF2-40B4-BE49-F238E27FC236}">
-                <a16:creationId xmlns:a16="http://schemas.microsoft.com/office/drawing/2014/main" id="{0187001C-1BB3-4B97-B81A-25A58CB5B058}"/>
+                <a16:creationId xmlns:a16="http://schemas.microsoft.com/office/drawing/2014/main" id="{AFFBF822-A664-464D-9A4A-1217CFE2D84E}"/>
               </a:ext>
             </a:extLst>
           </p:cNvPr>
@@ -9909,7 +9909,7 @@
           <p:cNvPr id="18" name="">
             <a:extLst xmlns:a="http://schemas.openxmlformats.org/drawingml/2006/main">
               <a:ext uri="{FF2B5EF4-FFF2-40B4-BE49-F238E27FC236}">
-                <a16:creationId xmlns:a16="http://schemas.microsoft.com/office/drawing/2014/main" id="{0E5B5AEF-0825-4C70-8C83-8FA4AD3B98E6}"/>
+                <a16:creationId xmlns:a16="http://schemas.microsoft.com/office/drawing/2014/main" id="{2A12BE87-AC69-473A-846A-172101AE6499}"/>
               </a:ext>
             </a:extLst>
           </p:cNvPr>
@@ -9942,7 +9942,7 @@
           <p:cNvPr id="19" name="">
             <a:extLst xmlns:a="http://schemas.openxmlformats.org/drawingml/2006/main">
               <a:ext uri="{FF2B5EF4-FFF2-40B4-BE49-F238E27FC236}">
-                <a16:creationId xmlns:a16="http://schemas.microsoft.com/office/drawing/2014/main" id="{0D8022F9-242C-489A-ABB7-C170FDABDD0A}"/>
+                <a16:creationId xmlns:a16="http://schemas.microsoft.com/office/drawing/2014/main" id="{F142BA47-DFF2-439F-92CE-5B8316F810CA}"/>
               </a:ext>
             </a:extLst>
           </p:cNvPr>
@@ -9992,7 +9992,7 @@
           <p:cNvPr id="20" name="">
             <a:extLst xmlns:a="http://schemas.openxmlformats.org/drawingml/2006/main">
               <a:ext uri="{FF2B5EF4-FFF2-40B4-BE49-F238E27FC236}">
-                <a16:creationId xmlns:a16="http://schemas.microsoft.com/office/drawing/2014/main" id="{B68466CE-CE09-459E-85A8-683569D2FDCE}"/>
+                <a16:creationId xmlns:a16="http://schemas.microsoft.com/office/drawing/2014/main" id="{86EEEDBB-771A-4E08-8CD5-C1A1F7F19580}"/>
               </a:ext>
             </a:extLst>
           </p:cNvPr>
@@ -10042,7 +10042,7 @@
           <p:cNvPr id="21" name="">
             <a:extLst xmlns:a="http://schemas.openxmlformats.org/drawingml/2006/main">
               <a:ext uri="{FF2B5EF4-FFF2-40B4-BE49-F238E27FC236}">
-                <a16:creationId xmlns:a16="http://schemas.microsoft.com/office/drawing/2014/main" id="{51748659-884B-49A8-BDBE-C56447402865}"/>
+                <a16:creationId xmlns:a16="http://schemas.microsoft.com/office/drawing/2014/main" id="{1794CDDF-38FF-4236-B725-77AECD33C619}"/>
               </a:ext>
             </a:extLst>
           </p:cNvPr>
@@ -10077,7 +10077,7 @@
           <p:cNvPr id="22" name="">
             <a:extLst xmlns:a="http://schemas.openxmlformats.org/drawingml/2006/main">
               <a:ext uri="{FF2B5EF4-FFF2-40B4-BE49-F238E27FC236}">
-                <a16:creationId xmlns:a16="http://schemas.microsoft.com/office/drawing/2014/main" id="{17A99A13-9115-4A3F-97FD-D3A17B1FE66A}"/>
+                <a16:creationId xmlns:a16="http://schemas.microsoft.com/office/drawing/2014/main" id="{35B6FBBD-226C-477E-8A65-11176D510400}"/>
               </a:ext>
             </a:extLst>
           </p:cNvPr>
@@ -10110,7 +10110,7 @@
           <p:cNvPr id="23" name="">
             <a:extLst xmlns:a="http://schemas.openxmlformats.org/drawingml/2006/main">
               <a:ext uri="{FF2B5EF4-FFF2-40B4-BE49-F238E27FC236}">
-                <a16:creationId xmlns:a16="http://schemas.microsoft.com/office/drawing/2014/main" id="{3A961A09-0C60-430F-A3DD-918622090655}"/>
+                <a16:creationId xmlns:a16="http://schemas.microsoft.com/office/drawing/2014/main" id="{438FFCFF-7AA3-4FEC-AF3E-7D88D0FD4E72}"/>
               </a:ext>
             </a:extLst>
           </p:cNvPr>
@@ -10160,7 +10160,7 @@
           <p:cNvPr id="24" name="">
             <a:extLst xmlns:a="http://schemas.openxmlformats.org/drawingml/2006/main">
               <a:ext uri="{FF2B5EF4-FFF2-40B4-BE49-F238E27FC236}">
-                <a16:creationId xmlns:a16="http://schemas.microsoft.com/office/drawing/2014/main" id="{24161472-3AA8-4C07-89E0-C94041E03080}"/>
+                <a16:creationId xmlns:a16="http://schemas.microsoft.com/office/drawing/2014/main" id="{6A9761F3-82B4-4092-AE9C-085F0F89F42D}"/>
               </a:ext>
             </a:extLst>
           </p:cNvPr>
@@ -10210,7 +10210,7 @@
           <p:cNvPr id="25" name="">
             <a:extLst xmlns:a="http://schemas.openxmlformats.org/drawingml/2006/main">
               <a:ext uri="{FF2B5EF4-FFF2-40B4-BE49-F238E27FC236}">
-                <a16:creationId xmlns:a16="http://schemas.microsoft.com/office/drawing/2014/main" id="{A3D7FD10-FC90-4938-AB9B-F69939E43781}"/>
+                <a16:creationId xmlns:a16="http://schemas.microsoft.com/office/drawing/2014/main" id="{53C62899-D78D-4183-A113-DF2DF2B2F3B0}"/>
               </a:ext>
             </a:extLst>
           </p:cNvPr>
@@ -10245,7 +10245,7 @@
           <p:cNvPr id="26" name="">
             <a:extLst xmlns:a="http://schemas.openxmlformats.org/drawingml/2006/main">
               <a:ext uri="{FF2B5EF4-FFF2-40B4-BE49-F238E27FC236}">
-                <a16:creationId xmlns:a16="http://schemas.microsoft.com/office/drawing/2014/main" id="{A77F2389-84AB-467C-9DBE-DECD1A99F245}"/>
+                <a16:creationId xmlns:a16="http://schemas.microsoft.com/office/drawing/2014/main" id="{3D7B9B2D-C8E4-4CD5-9369-82C4B8437BD9}"/>
               </a:ext>
             </a:extLst>
           </p:cNvPr>
@@ -10278,7 +10278,7 @@
           <p:cNvPr id="27" name="">
             <a:extLst xmlns:a="http://schemas.openxmlformats.org/drawingml/2006/main">
               <a:ext uri="{FF2B5EF4-FFF2-40B4-BE49-F238E27FC236}">
-                <a16:creationId xmlns:a16="http://schemas.microsoft.com/office/drawing/2014/main" id="{C2408DA3-B81B-491D-A222-9ADD0C601A05}"/>
+                <a16:creationId xmlns:a16="http://schemas.microsoft.com/office/drawing/2014/main" id="{3F4D04A2-F698-47CF-911D-06093AE5D23D}"/>
               </a:ext>
             </a:extLst>
           </p:cNvPr>
@@ -10328,7 +10328,7 @@
           <p:cNvPr id="28" name="">
             <a:extLst xmlns:a="http://schemas.openxmlformats.org/drawingml/2006/main">
               <a:ext uri="{FF2B5EF4-FFF2-40B4-BE49-F238E27FC236}">
-                <a16:creationId xmlns:a16="http://schemas.microsoft.com/office/drawing/2014/main" id="{02E12E14-91B5-453F-8B33-ADD2D3E5DEB8}"/>
+                <a16:creationId xmlns:a16="http://schemas.microsoft.com/office/drawing/2014/main" id="{E7123D20-300B-46CF-9990-832CE377E00D}"/>
               </a:ext>
             </a:extLst>
           </p:cNvPr>
@@ -10482,7 +10482,7 @@
           <p:cNvPr id="33" name="">
             <a:extLst xmlns:a="http://schemas.openxmlformats.org/drawingml/2006/main">
               <a:ext uri="{FF2B5EF4-FFF2-40B4-BE49-F238E27FC236}">
-                <a16:creationId xmlns:a16="http://schemas.microsoft.com/office/drawing/2014/main" id="{53781D45-219A-43AB-ABC7-6FF48C449FF0}"/>
+                <a16:creationId xmlns:a16="http://schemas.microsoft.com/office/drawing/2014/main" id="{91D63FA8-8946-447F-BF4B-A254143DA7E4}"/>
               </a:ext>
             </a:extLst>
           </p:cNvPr>
@@ -10517,7 +10517,7 @@
           <p:cNvPr id="34" name="">
             <a:extLst xmlns:a="http://schemas.openxmlformats.org/drawingml/2006/main">
               <a:ext uri="{FF2B5EF4-FFF2-40B4-BE49-F238E27FC236}">
-                <a16:creationId xmlns:a16="http://schemas.microsoft.com/office/drawing/2014/main" id="{6575521E-D8A3-4041-95CE-6AF059D06E10}"/>
+                <a16:creationId xmlns:a16="http://schemas.microsoft.com/office/drawing/2014/main" id="{D7516487-074A-4C3A-930F-87B4284967F1}"/>
               </a:ext>
             </a:extLst>
           </p:cNvPr>
@@ -10565,7 +10565,7 @@
     </p:spTree>
     <p:extLst>
       <p:ext uri="{BB962C8B-B14F-4D97-AF65-F5344CB8AC3E}">
-        <p14:creationId xmlns:p14="http://schemas.microsoft.com/office/powerpoint/2010/main" val="1721186643"/>
+        <p14:creationId xmlns:p14="http://schemas.microsoft.com/office/powerpoint/2010/main" val="1511969817"/>
       </p:ext>
     </p:extLst>
   </p:cSld>
@@ -10596,7 +10596,7 @@
           <p:cNvPr id="23" name="">
             <a:extLst xmlns:a="http://schemas.openxmlformats.org/drawingml/2006/main">
               <a:ext uri="{FF2B5EF4-FFF2-40B4-BE49-F238E27FC236}">
-                <a16:creationId xmlns:a16="http://schemas.microsoft.com/office/drawing/2014/main" id="{00BCB4BD-FED8-43DA-80C4-668B8AA207B7}"/>
+                <a16:creationId xmlns:a16="http://schemas.microsoft.com/office/drawing/2014/main" id="{54B05D41-1F34-4BE9-8D17-75A559B803F5}"/>
               </a:ext>
             </a:extLst>
           </p:cNvPr>
@@ -10627,7 +10627,7 @@
           <p:cNvPr id="2" name="">
             <a:extLst xmlns:a="http://schemas.openxmlformats.org/drawingml/2006/main">
               <a:ext uri="{FF2B5EF4-FFF2-40B4-BE49-F238E27FC236}">
-                <a16:creationId xmlns:a16="http://schemas.microsoft.com/office/drawing/2014/main" id="{BB0C6289-31B9-48A5-B4CA-1D8EAD4F582C}"/>
+                <a16:creationId xmlns:a16="http://schemas.microsoft.com/office/drawing/2014/main" id="{0790D332-EE12-43E9-BA7B-AC1BFC0F888F}"/>
               </a:ext>
             </a:extLst>
           </p:cNvPr>
@@ -10667,7 +10667,7 @@
                   <a:srgbClr val="FF7A00"/>
                 </a:solidFill>
               </a:rPr>
-              <a:t>DEMO SEQUENCE</a:t>
+              <a:t>TEST RESPONSIBILITIES</a:t>
             </a:r>
           </a:p>
         </p:txBody>
@@ -10677,7 +10677,7 @@
           <p:cNvPr id="3" name="">
             <a:extLst xmlns:a="http://schemas.openxmlformats.org/drawingml/2006/main">
               <a:ext uri="{FF2B5EF4-FFF2-40B4-BE49-F238E27FC236}">
-                <a16:creationId xmlns:a16="http://schemas.microsoft.com/office/drawing/2014/main" id="{9E941B87-EBC9-45CF-AFBF-C567B0DF4A12}"/>
+                <a16:creationId xmlns:a16="http://schemas.microsoft.com/office/drawing/2014/main" id="{F116569F-D6B1-4B3E-9389-9643B76F36BC}"/>
               </a:ext>
             </a:extLst>
           </p:cNvPr>
@@ -10727,7 +10727,7 @@
           <p:cNvPr id="4" name="">
             <a:extLst xmlns:a="http://schemas.openxmlformats.org/drawingml/2006/main">
               <a:ext uri="{FF2B5EF4-FFF2-40B4-BE49-F238E27FC236}">
-                <a16:creationId xmlns:a16="http://schemas.microsoft.com/office/drawing/2014/main" id="{127F8AEB-C777-4E0D-9E13-AE703C2F8FD8}"/>
+                <a16:creationId xmlns:a16="http://schemas.microsoft.com/office/drawing/2014/main" id="{ADAAE0ED-97F1-42D3-B388-38615297A470}"/>
               </a:ext>
             </a:extLst>
           </p:cNvPr>
@@ -10758,7 +10758,7 @@
           <p:cNvPr id="5" name="">
             <a:extLst xmlns:a="http://schemas.openxmlformats.org/drawingml/2006/main">
               <a:ext uri="{FF2B5EF4-FFF2-40B4-BE49-F238E27FC236}">
-                <a16:creationId xmlns:a16="http://schemas.microsoft.com/office/drawing/2014/main" id="{B640FA63-145A-42E7-9583-A96CA969FFDC}"/>
+                <a16:creationId xmlns:a16="http://schemas.microsoft.com/office/drawing/2014/main" id="{AE22AA2D-20CF-4EAD-BF2D-9B7B30874DCA}"/>
               </a:ext>
             </a:extLst>
           </p:cNvPr>
@@ -10808,7 +10808,7 @@
           <p:cNvPr id="6" name="">
             <a:extLst xmlns:a="http://schemas.openxmlformats.org/drawingml/2006/main">
               <a:ext uri="{FF2B5EF4-FFF2-40B4-BE49-F238E27FC236}">
-                <a16:creationId xmlns:a16="http://schemas.microsoft.com/office/drawing/2014/main" id="{52B88211-5202-4468-B652-F501114E21D4}"/>
+                <a16:creationId xmlns:a16="http://schemas.microsoft.com/office/drawing/2014/main" id="{31D71AA9-58D6-4D5F-A6AE-25643CAD6D3F}"/>
               </a:ext>
             </a:extLst>
           </p:cNvPr>
@@ -10848,7 +10848,7 @@
                   <a:srgbClr val="F7F8FA"/>
                 </a:solidFill>
               </a:rPr>
-              <a:t>Ten minutes, three pieces of evidence</a:t>
+              <a:t>The POC proves behavior—not a finished platform.</a:t>
             </a:r>
           </a:p>
         </p:txBody>
@@ -10858,7 +10858,7 @@
           <p:cNvPr id="7" name="">
             <a:extLst xmlns:a="http://schemas.openxmlformats.org/drawingml/2006/main">
               <a:ext uri="{FF2B5EF4-FFF2-40B4-BE49-F238E27FC236}">
-                <a16:creationId xmlns:a16="http://schemas.microsoft.com/office/drawing/2014/main" id="{D6F7DF58-6131-491B-B3E9-EB7583FD78FF}"/>
+                <a16:creationId xmlns:a16="http://schemas.microsoft.com/office/drawing/2014/main" id="{746194AD-759F-4482-A7A8-933AE5CB7C9F}"/>
               </a:ext>
             </a:extLst>
           </p:cNvPr>
@@ -10891,7 +10891,7 @@
           <p:cNvPr id="8" name="">
             <a:extLst xmlns:a="http://schemas.openxmlformats.org/drawingml/2006/main">
               <a:ext uri="{FF2B5EF4-FFF2-40B4-BE49-F238E27FC236}">
-                <a16:creationId xmlns:a16="http://schemas.microsoft.com/office/drawing/2014/main" id="{D4527ABD-E9FA-4FC9-A688-C847A26D859D}"/>
+                <a16:creationId xmlns:a16="http://schemas.microsoft.com/office/drawing/2014/main" id="{665826E6-D926-4A93-83BD-AC129042E02F}"/>
               </a:ext>
             </a:extLst>
           </p:cNvPr>
@@ -10931,7 +10931,7 @@
                   <a:srgbClr val="AAB3C0"/>
                 </a:solidFill>
               </a:rPr>
-              <a:t>Keep the walkthrough focused on behavior, not file-by-file narration.</a:t>
+              <a:t>Each layer has a different test responsibility.</a:t>
             </a:r>
           </a:p>
         </p:txBody>
@@ -10941,7 +10941,7 @@
           <p:cNvPr id="9" name="">
             <a:extLst xmlns:a="http://schemas.openxmlformats.org/drawingml/2006/main">
               <a:ext uri="{FF2B5EF4-FFF2-40B4-BE49-F238E27FC236}">
-                <a16:creationId xmlns:a16="http://schemas.microsoft.com/office/drawing/2014/main" id="{41E4D5FD-35AF-467D-8AF7-E7B7D66A374D}"/>
+                <a16:creationId xmlns:a16="http://schemas.microsoft.com/office/drawing/2014/main" id="{47D6D8BC-4FAB-45A0-AD28-2A0262B1D65C}"/>
               </a:ext>
             </a:extLst>
           </p:cNvPr>
@@ -10974,7 +10974,7 @@
           <p:cNvPr id="10" name="">
             <a:extLst xmlns:a="http://schemas.openxmlformats.org/drawingml/2006/main">
               <a:ext uri="{FF2B5EF4-FFF2-40B4-BE49-F238E27FC236}">
-                <a16:creationId xmlns:a16="http://schemas.microsoft.com/office/drawing/2014/main" id="{1E9DEB2E-B624-47CC-850A-FEE5688C14B6}"/>
+                <a16:creationId xmlns:a16="http://schemas.microsoft.com/office/drawing/2014/main" id="{767002D9-C859-427F-883B-163F5D182973}"/>
               </a:ext>
             </a:extLst>
           </p:cNvPr>
@@ -11024,7 +11024,7 @@
           <p:cNvPr id="11" name="">
             <a:extLst xmlns:a="http://schemas.openxmlformats.org/drawingml/2006/main">
               <a:ext uri="{FF2B5EF4-FFF2-40B4-BE49-F238E27FC236}">
-                <a16:creationId xmlns:a16="http://schemas.microsoft.com/office/drawing/2014/main" id="{29B91F87-6FB6-4655-8B98-7E5D8944C700}"/>
+                <a16:creationId xmlns:a16="http://schemas.microsoft.com/office/drawing/2014/main" id="{2BCF1B1B-0244-40EA-843D-8B3016573F5A}"/>
               </a:ext>
             </a:extLst>
           </p:cNvPr>
@@ -11064,7 +11064,7 @@
                   <a:srgbClr val="F7F8FA"/>
                 </a:solidFill>
               </a:rPr>
-              <a:t>Create</a:t>
+              <a:t>Lifecycle regression</a:t>
             </a:r>
           </a:p>
         </p:txBody>
@@ -11074,7 +11074,7 @@
           <p:cNvPr id="12" name="">
             <a:extLst xmlns:a="http://schemas.openxmlformats.org/drawingml/2006/main">
               <a:ext uri="{FF2B5EF4-FFF2-40B4-BE49-F238E27FC236}">
-                <a16:creationId xmlns:a16="http://schemas.microsoft.com/office/drawing/2014/main" id="{315649FD-EA5B-4218-B5F6-8223E5FD182D}"/>
+                <a16:creationId xmlns:a16="http://schemas.microsoft.com/office/drawing/2014/main" id="{560E424E-D109-47F3-9173-5384970575F3}"/>
               </a:ext>
             </a:extLst>
           </p:cNvPr>
@@ -11114,7 +11114,7 @@
                   <a:srgbClr val="AAB3C0"/>
                 </a:solidFill>
               </a:rPr>
-              <a:t>Approved event becomes one manifest with provenance.</a:t>
+              <a:t>Playbooks prove manifest creation, blocked-to-ready transitions, stale-revision rejection, and replay safety.</a:t>
             </a:r>
           </a:p>
         </p:txBody>
@@ -11124,7 +11124,7 @@
           <p:cNvPr id="13" name="">
             <a:extLst xmlns:a="http://schemas.openxmlformats.org/drawingml/2006/main">
               <a:ext uri="{FF2B5EF4-FFF2-40B4-BE49-F238E27FC236}">
-                <a16:creationId xmlns:a16="http://schemas.microsoft.com/office/drawing/2014/main" id="{835367D4-F623-428D-937C-458CBC36D9CC}"/>
+                <a16:creationId xmlns:a16="http://schemas.microsoft.com/office/drawing/2014/main" id="{45F66A7C-268F-44D8-AC6B-E938F07EE155}"/>
               </a:ext>
             </a:extLst>
           </p:cNvPr>
@@ -11157,7 +11157,7 @@
           <p:cNvPr id="14" name="">
             <a:extLst xmlns:a="http://schemas.openxmlformats.org/drawingml/2006/main">
               <a:ext uri="{FF2B5EF4-FFF2-40B4-BE49-F238E27FC236}">
-                <a16:creationId xmlns:a16="http://schemas.microsoft.com/office/drawing/2014/main" id="{746B9F45-7B50-4575-B5E1-52D24452B379}"/>
+                <a16:creationId xmlns:a16="http://schemas.microsoft.com/office/drawing/2014/main" id="{AA04E653-05AD-4858-ABEA-6B6B9F18A530}"/>
               </a:ext>
             </a:extLst>
           </p:cNvPr>
@@ -11207,7 +11207,7 @@
           <p:cNvPr id="15" name="">
             <a:extLst xmlns:a="http://schemas.openxmlformats.org/drawingml/2006/main">
               <a:ext uri="{FF2B5EF4-FFF2-40B4-BE49-F238E27FC236}">
-                <a16:creationId xmlns:a16="http://schemas.microsoft.com/office/drawing/2014/main" id="{A04273A6-E15E-4905-BC82-B08E7C8F04E9}"/>
+                <a16:creationId xmlns:a16="http://schemas.microsoft.com/office/drawing/2014/main" id="{8D4C8F6F-D8C6-4C2E-9B5E-D74BFB485A92}"/>
               </a:ext>
             </a:extLst>
           </p:cNvPr>
@@ -11247,7 +11247,7 @@
                   <a:srgbClr val="F7F8FA"/>
                 </a:solidFill>
               </a:rPr>
-              <a:t>Block + resume</a:t>
+              <a:t>Molecule role tests</a:t>
             </a:r>
           </a:p>
         </p:txBody>
@@ -11257,7 +11257,7 @@
           <p:cNvPr id="16" name="">
             <a:extLst xmlns:a="http://schemas.openxmlformats.org/drawingml/2006/main">
               <a:ext uri="{FF2B5EF4-FFF2-40B4-BE49-F238E27FC236}">
-                <a16:creationId xmlns:a16="http://schemas.microsoft.com/office/drawing/2014/main" id="{10B1BDAA-F70B-4472-B826-5D382BE8168F}"/>
+                <a16:creationId xmlns:a16="http://schemas.microsoft.com/office/drawing/2014/main" id="{6D0F69CC-CB44-4155-B84E-EEA4049FC4CF}"/>
               </a:ext>
             </a:extLst>
           </p:cNvPr>
@@ -11297,7 +11297,7 @@
                   <a:srgbClr val="AAB3C0"/>
                 </a:solidFill>
               </a:rPr>
-              <a:t>Windows and Linux expose different blockers through one lifecycle.</a:t>
+              <a:t>Each role runs in a controlled execution environment, converges, verifies its artifacts, repeats idempotently, and exercises expected failures.</a:t>
             </a:r>
           </a:p>
         </p:txBody>
@@ -11307,7 +11307,7 @@
           <p:cNvPr id="17" name="">
             <a:extLst xmlns:a="http://schemas.openxmlformats.org/drawingml/2006/main">
               <a:ext uri="{FF2B5EF4-FFF2-40B4-BE49-F238E27FC236}">
-                <a16:creationId xmlns:a16="http://schemas.microsoft.com/office/drawing/2014/main" id="{2E62DF75-208C-42BF-8DDC-25871E5A329A}"/>
+                <a16:creationId xmlns:a16="http://schemas.microsoft.com/office/drawing/2014/main" id="{8F2FE558-6E78-4D33-AAC1-AE71B258350C}"/>
               </a:ext>
             </a:extLst>
           </p:cNvPr>
@@ -11340,7 +11340,7 @@
           <p:cNvPr id="18" name="">
             <a:extLst xmlns:a="http://schemas.openxmlformats.org/drawingml/2006/main">
               <a:ext uri="{FF2B5EF4-FFF2-40B4-BE49-F238E27FC236}">
-                <a16:creationId xmlns:a16="http://schemas.microsoft.com/office/drawing/2014/main" id="{FC0754AC-2D12-4FAA-AF39-E88CA6E34F01}"/>
+                <a16:creationId xmlns:a16="http://schemas.microsoft.com/office/drawing/2014/main" id="{C6300064-5934-47F1-A412-08F2554A547F}"/>
               </a:ext>
             </a:extLst>
           </p:cNvPr>
@@ -11390,7 +11390,7 @@
           <p:cNvPr id="19" name="">
             <a:extLst xmlns:a="http://schemas.openxmlformats.org/drawingml/2006/main">
               <a:ext uri="{FF2B5EF4-FFF2-40B4-BE49-F238E27FC236}">
-                <a16:creationId xmlns:a16="http://schemas.microsoft.com/office/drawing/2014/main" id="{CB67F0D8-C3E3-4940-8E7E-AD3554AE3203}"/>
+                <a16:creationId xmlns:a16="http://schemas.microsoft.com/office/drawing/2014/main" id="{0E7A30F0-AA71-437D-AD1A-3A0C27A740D2}"/>
               </a:ext>
             </a:extLst>
           </p:cNvPr>
@@ -11430,7 +11430,7 @@
                   <a:srgbClr val="F7F8FA"/>
                 </a:solidFill>
               </a:rPr>
-              <a:t>Test</a:t>
+              <a:t>AAP workflow validation</a:t>
             </a:r>
           </a:p>
         </p:txBody>
@@ -11440,7 +11440,7 @@
           <p:cNvPr id="20" name="">
             <a:extLst xmlns:a="http://schemas.openxmlformats.org/drawingml/2006/main">
               <a:ext uri="{FF2B5EF4-FFF2-40B4-BE49-F238E27FC236}">
-                <a16:creationId xmlns:a16="http://schemas.microsoft.com/office/drawing/2014/main" id="{CB78CB3E-0C27-4B0C-BB17-365A5F07209F}"/>
+                <a16:creationId xmlns:a16="http://schemas.microsoft.com/office/drawing/2014/main" id="{48570166-E2FD-4D39-BA32-3DF74FE4CA42}"/>
               </a:ext>
             </a:extLst>
           </p:cNvPr>
@@ -11480,7 +11480,7 @@
                   <a:srgbClr val="AAB3C0"/>
                 </a:solidFill>
               </a:rPr>
-              <a:t>Molecule proves convergence, idempotence, and expected failures.</a:t>
+              <a:t>Non-production AAP will prove job-template branching, credential boundaries, and phase orchestration.</a:t>
             </a:r>
           </a:p>
         </p:txBody>
@@ -11490,23 +11490,23 @@
           <p:cNvPr id="21" name="">
             <a:extLst xmlns:a="http://schemas.openxmlformats.org/drawingml/2006/main">
               <a:ext uri="{FF2B5EF4-FFF2-40B4-BE49-F238E27FC236}">
-                <a16:creationId xmlns:a16="http://schemas.microsoft.com/office/drawing/2014/main" id="{3B46F803-D2F8-4021-903A-9C2CCBB97D78}"/>
-              </a:ext>
-            </a:extLst>
-          </p:cNvPr>
-          <p:cNvSpPr>
-            <a:spLocks xmlns:a="http://schemas.openxmlformats.org/drawingml/2006/main" noGrp="1"/>
-          </p:cNvSpPr>
-          <p:nvPr/>
-        </p:nvSpPr>
-        <p:spPr>
-          <a:xfrm xmlns:a="http://schemas.openxmlformats.org/drawingml/2006/main">
-            <a:off x="1657350" y="5753100"/>
-            <a:ext cx="9201150" cy="361950"/>
+                <a16:creationId xmlns:a16="http://schemas.microsoft.com/office/drawing/2014/main" id="{F8AF33EA-F015-462E-80EC-9BF1A3F7DD3B}"/>
+              </a:ext>
+            </a:extLst>
+          </p:cNvPr>
+          <p:cNvSpPr>
+            <a:spLocks xmlns:a="http://schemas.openxmlformats.org/drawingml/2006/main" noGrp="1"/>
+          </p:cNvSpPr>
+          <p:nvPr/>
+        </p:nvSpPr>
+        <p:spPr>
+          <a:xfrm xmlns:a="http://schemas.openxmlformats.org/drawingml/2006/main">
+            <a:off x="1257300" y="5600700"/>
+            <a:ext cx="9677400" cy="514350"/>
           </a:xfrm>
           <a:prstGeom xmlns:a="http://schemas.openxmlformats.org/drawingml/2006/main" prst="roundRect">
             <a:avLst>
-              <a:gd name="adj" fmla="val 26316"/>
+              <a:gd name="adj" fmla="val 18519"/>
             </a:avLst>
           </a:prstGeom>
           <a:solidFill xmlns:a="http://schemas.openxmlformats.org/drawingml/2006/main">
@@ -11525,19 +11525,19 @@
           <p:cNvPr id="22" name="">
             <a:extLst xmlns:a="http://schemas.openxmlformats.org/drawingml/2006/main">
               <a:ext uri="{FF2B5EF4-FFF2-40B4-BE49-F238E27FC236}">
-                <a16:creationId xmlns:a16="http://schemas.microsoft.com/office/drawing/2014/main" id="{7260640A-CAB4-4E7B-BED8-E394B64E8F13}"/>
-              </a:ext>
-            </a:extLst>
-          </p:cNvPr>
-          <p:cNvSpPr>
-            <a:spLocks xmlns:a="http://schemas.openxmlformats.org/drawingml/2006/main" noGrp="1"/>
-          </p:cNvSpPr>
-          <p:nvPr/>
-        </p:nvSpPr>
-        <p:spPr>
-          <a:xfrm xmlns:a="http://schemas.openxmlformats.org/drawingml/2006/main">
-            <a:off x="1885950" y="5829300"/>
-            <a:ext cx="8667750" cy="228600"/>
+                <a16:creationId xmlns:a16="http://schemas.microsoft.com/office/drawing/2014/main" id="{518C2B54-3EC9-4063-9F48-D2E8D8F35CD3}"/>
+              </a:ext>
+            </a:extLst>
+          </p:cNvPr>
+          <p:cNvSpPr>
+            <a:spLocks xmlns:a="http://schemas.openxmlformats.org/drawingml/2006/main" noGrp="1"/>
+          </p:cNvSpPr>
+          <p:nvPr/>
+        </p:nvSpPr>
+        <p:spPr>
+          <a:xfrm xmlns:a="http://schemas.openxmlformats.org/drawingml/2006/main">
+            <a:off x="1562100" y="5734050"/>
+            <a:ext cx="9067800" cy="285750"/>
           </a:xfrm>
           <a:prstGeom xmlns:a="http://schemas.openxmlformats.org/drawingml/2006/main" prst="rect">
             <a:avLst/>
@@ -11553,19 +11553,19 @@
           <a:lstStyle xmlns:a="http://schemas.openxmlformats.org/drawingml/2006/main"/>
           <a:p xmlns:a="http://schemas.openxmlformats.org/drawingml/2006/main">
             <a:pPr algn="ctr">
-              <a:defRPr sz="1125" b="1">
+              <a:defRPr sz="1275" b="1">
                 <a:solidFill>
                   <a:srgbClr val="AAB3C0"/>
                 </a:solidFill>
               </a:defRPr>
             </a:pPr>
             <a:r>
-              <a:rPr sz="1125" b="1">
+              <a:rPr sz="1275" b="1">
                 <a:solidFill>
                   <a:srgbClr val="AAB3C0"/>
                 </a:solidFill>
               </a:rPr>
-              <a:t>Fallback: checked-in synthetic fixtures + process views + latest CI evidence.</a:t>
+              <a:t>Molecule does not simulate AAP. It proves a role’s contract before that role is promoted into an AAP workflow.</a:t>
             </a:r>
           </a:p>
         </p:txBody>
@@ -11573,7 +11573,7 @@
     </p:spTree>
     <p:extLst>
       <p:ext uri="{BB962C8B-B14F-4D97-AF65-F5344CB8AC3E}">
-        <p14:creationId xmlns:p14="http://schemas.microsoft.com/office/powerpoint/2010/main" val="1932629136"/>
+        <p14:creationId xmlns:p14="http://schemas.microsoft.com/office/powerpoint/2010/main" val="637542786"/>
       </p:ext>
     </p:extLst>
   </p:cSld>
@@ -11604,7 +11604,7 @@
           <p:cNvPr id="31" name="">
             <a:extLst xmlns:a="http://schemas.openxmlformats.org/drawingml/2006/main">
               <a:ext uri="{FF2B5EF4-FFF2-40B4-BE49-F238E27FC236}">
-                <a16:creationId xmlns:a16="http://schemas.microsoft.com/office/drawing/2014/main" id="{50968BCC-81F9-498A-9C4D-3A11D71A0CB3}"/>
+                <a16:creationId xmlns:a16="http://schemas.microsoft.com/office/drawing/2014/main" id="{C0CE7293-05A2-4344-A45B-C71D45429E08}"/>
               </a:ext>
             </a:extLst>
           </p:cNvPr>
@@ -11635,7 +11635,7 @@
           <p:cNvPr id="2" name="">
             <a:extLst xmlns:a="http://schemas.openxmlformats.org/drawingml/2006/main">
               <a:ext uri="{FF2B5EF4-FFF2-40B4-BE49-F238E27FC236}">
-                <a16:creationId xmlns:a16="http://schemas.microsoft.com/office/drawing/2014/main" id="{474EC319-AF48-470C-87BD-A57BA2E78AAB}"/>
+                <a16:creationId xmlns:a16="http://schemas.microsoft.com/office/drawing/2014/main" id="{B00D437A-480A-4AB6-B2AF-44ABF7C70ADE}"/>
               </a:ext>
             </a:extLst>
           </p:cNvPr>
@@ -11685,7 +11685,7 @@
           <p:cNvPr id="3" name="">
             <a:extLst xmlns:a="http://schemas.openxmlformats.org/drawingml/2006/main">
               <a:ext uri="{FF2B5EF4-FFF2-40B4-BE49-F238E27FC236}">
-                <a16:creationId xmlns:a16="http://schemas.microsoft.com/office/drawing/2014/main" id="{71EB0E0B-A1D4-464B-81AD-74B7569665BA}"/>
+                <a16:creationId xmlns:a16="http://schemas.microsoft.com/office/drawing/2014/main" id="{370DC50E-74A4-43D9-9BA0-5D4773842025}"/>
               </a:ext>
             </a:extLst>
           </p:cNvPr>
@@ -11735,7 +11735,7 @@
           <p:cNvPr id="4" name="">
             <a:extLst xmlns:a="http://schemas.openxmlformats.org/drawingml/2006/main">
               <a:ext uri="{FF2B5EF4-FFF2-40B4-BE49-F238E27FC236}">
-                <a16:creationId xmlns:a16="http://schemas.microsoft.com/office/drawing/2014/main" id="{4446891E-E762-430D-8386-FFFAEE8691BC}"/>
+                <a16:creationId xmlns:a16="http://schemas.microsoft.com/office/drawing/2014/main" id="{47362A9C-9B28-440F-B5F3-FF2D49E2069E}"/>
               </a:ext>
             </a:extLst>
           </p:cNvPr>
@@ -11766,7 +11766,7 @@
           <p:cNvPr id="5" name="">
             <a:extLst xmlns:a="http://schemas.openxmlformats.org/drawingml/2006/main">
               <a:ext uri="{FF2B5EF4-FFF2-40B4-BE49-F238E27FC236}">
-                <a16:creationId xmlns:a16="http://schemas.microsoft.com/office/drawing/2014/main" id="{1BAB99BF-9221-4F38-84DA-3C5310F4237D}"/>
+                <a16:creationId xmlns:a16="http://schemas.microsoft.com/office/drawing/2014/main" id="{FB9FA982-4CA5-4951-812D-8B68BEA47305}"/>
               </a:ext>
             </a:extLst>
           </p:cNvPr>
@@ -11816,7 +11816,7 @@
           <p:cNvPr id="6" name="">
             <a:extLst xmlns:a="http://schemas.openxmlformats.org/drawingml/2006/main">
               <a:ext uri="{FF2B5EF4-FFF2-40B4-BE49-F238E27FC236}">
-                <a16:creationId xmlns:a16="http://schemas.microsoft.com/office/drawing/2014/main" id="{233E0EBD-9B4A-42C4-8DA4-DEBD681FF17B}"/>
+                <a16:creationId xmlns:a16="http://schemas.microsoft.com/office/drawing/2014/main" id="{A0D2458E-C153-4A61-AC10-2D325F52D105}"/>
               </a:ext>
             </a:extLst>
           </p:cNvPr>
@@ -11866,7 +11866,7 @@
           <p:cNvPr id="7" name="">
             <a:extLst xmlns:a="http://schemas.openxmlformats.org/drawingml/2006/main">
               <a:ext uri="{FF2B5EF4-FFF2-40B4-BE49-F238E27FC236}">
-                <a16:creationId xmlns:a16="http://schemas.microsoft.com/office/drawing/2014/main" id="{261A2A26-A6FD-4937-8AB6-8683BBA0240D}"/>
+                <a16:creationId xmlns:a16="http://schemas.microsoft.com/office/drawing/2014/main" id="{4153B108-1DB0-415B-8C04-6A39EF8DE6AF}"/>
               </a:ext>
             </a:extLst>
           </p:cNvPr>
@@ -11899,7 +11899,7 @@
           <p:cNvPr id="8" name="">
             <a:extLst xmlns:a="http://schemas.openxmlformats.org/drawingml/2006/main">
               <a:ext uri="{FF2B5EF4-FFF2-40B4-BE49-F238E27FC236}">
-                <a16:creationId xmlns:a16="http://schemas.microsoft.com/office/drawing/2014/main" id="{5281AF64-C64F-436C-8606-DFAA8DFA25F6}"/>
+                <a16:creationId xmlns:a16="http://schemas.microsoft.com/office/drawing/2014/main" id="{C49073D6-FE46-48ED-911D-CB0EE20EDB68}"/>
               </a:ext>
             </a:extLst>
           </p:cNvPr>
@@ -11949,7 +11949,7 @@
           <p:cNvPr id="9" name="">
             <a:extLst xmlns:a="http://schemas.openxmlformats.org/drawingml/2006/main">
               <a:ext uri="{FF2B5EF4-FFF2-40B4-BE49-F238E27FC236}">
-                <a16:creationId xmlns:a16="http://schemas.microsoft.com/office/drawing/2014/main" id="{468F4A17-E3E9-43FC-8ECF-48EC87BF6564}"/>
+                <a16:creationId xmlns:a16="http://schemas.microsoft.com/office/drawing/2014/main" id="{C02EFFAD-EC80-4C9A-894D-A2B439BC9D5B}"/>
               </a:ext>
             </a:extLst>
           </p:cNvPr>
@@ -11984,7 +11984,7 @@
           <p:cNvPr id="10" name="">
             <a:extLst xmlns:a="http://schemas.openxmlformats.org/drawingml/2006/main">
               <a:ext uri="{FF2B5EF4-FFF2-40B4-BE49-F238E27FC236}">
-                <a16:creationId xmlns:a16="http://schemas.microsoft.com/office/drawing/2014/main" id="{B20F79A8-FDD2-4003-A636-97EBCE18314C}"/>
+                <a16:creationId xmlns:a16="http://schemas.microsoft.com/office/drawing/2014/main" id="{3DFF4591-8A53-4C8F-A7C0-0B933ACB2B13}"/>
               </a:ext>
             </a:extLst>
           </p:cNvPr>
@@ -12017,7 +12017,7 @@
           <p:cNvPr id="11" name="">
             <a:extLst xmlns:a="http://schemas.openxmlformats.org/drawingml/2006/main">
               <a:ext uri="{FF2B5EF4-FFF2-40B4-BE49-F238E27FC236}">
-                <a16:creationId xmlns:a16="http://schemas.microsoft.com/office/drawing/2014/main" id="{DC68D64D-58EF-47EA-8748-0B43C7B4B3EB}"/>
+                <a16:creationId xmlns:a16="http://schemas.microsoft.com/office/drawing/2014/main" id="{53693497-8D0E-4E66-A6B6-7C20DABE9DBF}"/>
               </a:ext>
             </a:extLst>
           </p:cNvPr>
@@ -12067,7 +12067,7 @@
           <p:cNvPr id="12" name="">
             <a:extLst xmlns:a="http://schemas.openxmlformats.org/drawingml/2006/main">
               <a:ext uri="{FF2B5EF4-FFF2-40B4-BE49-F238E27FC236}">
-                <a16:creationId xmlns:a16="http://schemas.microsoft.com/office/drawing/2014/main" id="{6590C105-4491-48C5-9B6F-FD81B7AF193C}"/>
+                <a16:creationId xmlns:a16="http://schemas.microsoft.com/office/drawing/2014/main" id="{C6B7901E-679B-4088-9570-70D5F14434E9}"/>
               </a:ext>
             </a:extLst>
           </p:cNvPr>
@@ -12134,7 +12134,7 @@
           <p:cNvPr id="13" name="">
             <a:extLst xmlns:a="http://schemas.openxmlformats.org/drawingml/2006/main">
               <a:ext uri="{FF2B5EF4-FFF2-40B4-BE49-F238E27FC236}">
-                <a16:creationId xmlns:a16="http://schemas.microsoft.com/office/drawing/2014/main" id="{2E388223-D961-45A5-8F1F-7C3AE1348258}"/>
+                <a16:creationId xmlns:a16="http://schemas.microsoft.com/office/drawing/2014/main" id="{C5CBC4DD-12B7-4CDA-AD25-D8B872105658}"/>
               </a:ext>
             </a:extLst>
           </p:cNvPr>
@@ -12169,7 +12169,7 @@
           <p:cNvPr id="14" name="">
             <a:extLst xmlns:a="http://schemas.openxmlformats.org/drawingml/2006/main">
               <a:ext uri="{FF2B5EF4-FFF2-40B4-BE49-F238E27FC236}">
-                <a16:creationId xmlns:a16="http://schemas.microsoft.com/office/drawing/2014/main" id="{2513A39A-6500-4588-A956-F5B1083A3B68}"/>
+                <a16:creationId xmlns:a16="http://schemas.microsoft.com/office/drawing/2014/main" id="{3B1303BB-1BB7-4814-93FE-E2BFA5B8335A}"/>
               </a:ext>
             </a:extLst>
           </p:cNvPr>
@@ -12202,7 +12202,7 @@
           <p:cNvPr id="15" name="">
             <a:extLst xmlns:a="http://schemas.openxmlformats.org/drawingml/2006/main">
               <a:ext uri="{FF2B5EF4-FFF2-40B4-BE49-F238E27FC236}">
-                <a16:creationId xmlns:a16="http://schemas.microsoft.com/office/drawing/2014/main" id="{80B1F298-3FBE-4347-8AE9-F7EFAECECC00}"/>
+                <a16:creationId xmlns:a16="http://schemas.microsoft.com/office/drawing/2014/main" id="{6029F804-39CA-4608-B544-D6F17441C79C}"/>
               </a:ext>
             </a:extLst>
           </p:cNvPr>
@@ -12252,7 +12252,7 @@
           <p:cNvPr id="16" name="">
             <a:extLst xmlns:a="http://schemas.openxmlformats.org/drawingml/2006/main">
               <a:ext uri="{FF2B5EF4-FFF2-40B4-BE49-F238E27FC236}">
-                <a16:creationId xmlns:a16="http://schemas.microsoft.com/office/drawing/2014/main" id="{232B129A-0B53-4D81-B4FE-3D519254277E}"/>
+                <a16:creationId xmlns:a16="http://schemas.microsoft.com/office/drawing/2014/main" id="{AB807344-9182-4F94-AB9E-B8C6BDB2A5B7}"/>
               </a:ext>
             </a:extLst>
           </p:cNvPr>
@@ -12319,7 +12319,7 @@
           <p:cNvPr id="17" name="">
             <a:extLst xmlns:a="http://schemas.openxmlformats.org/drawingml/2006/main">
               <a:ext uri="{FF2B5EF4-FFF2-40B4-BE49-F238E27FC236}">
-                <a16:creationId xmlns:a16="http://schemas.microsoft.com/office/drawing/2014/main" id="{2EF10885-614C-462A-B43B-2DCC26175F32}"/>
+                <a16:creationId xmlns:a16="http://schemas.microsoft.com/office/drawing/2014/main" id="{AB5075B5-9303-4306-9EA7-F813721C7E86}"/>
               </a:ext>
             </a:extLst>
           </p:cNvPr>
@@ -12354,7 +12354,7 @@
           <p:cNvPr id="18" name="">
             <a:extLst xmlns:a="http://schemas.openxmlformats.org/drawingml/2006/main">
               <a:ext uri="{FF2B5EF4-FFF2-40B4-BE49-F238E27FC236}">
-                <a16:creationId xmlns:a16="http://schemas.microsoft.com/office/drawing/2014/main" id="{86681935-2C1A-4C42-BF05-F9780010322A}"/>
+                <a16:creationId xmlns:a16="http://schemas.microsoft.com/office/drawing/2014/main" id="{9C746934-7DBC-4DAF-AD0D-70A028C10DB4}"/>
               </a:ext>
             </a:extLst>
           </p:cNvPr>
@@ -12387,7 +12387,7 @@
           <p:cNvPr id="19" name="">
             <a:extLst xmlns:a="http://schemas.openxmlformats.org/drawingml/2006/main">
               <a:ext uri="{FF2B5EF4-FFF2-40B4-BE49-F238E27FC236}">
-                <a16:creationId xmlns:a16="http://schemas.microsoft.com/office/drawing/2014/main" id="{52ACD3B5-B1A6-44DB-8862-DD9A58D38AE6}"/>
+                <a16:creationId xmlns:a16="http://schemas.microsoft.com/office/drawing/2014/main" id="{7DB34A91-CC0D-4BD0-92B7-9F05618EBDBC}"/>
               </a:ext>
             </a:extLst>
           </p:cNvPr>
@@ -12437,7 +12437,7 @@
           <p:cNvPr id="20" name="">
             <a:extLst xmlns:a="http://schemas.openxmlformats.org/drawingml/2006/main">
               <a:ext uri="{FF2B5EF4-FFF2-40B4-BE49-F238E27FC236}">
-                <a16:creationId xmlns:a16="http://schemas.microsoft.com/office/drawing/2014/main" id="{2F905D6D-64B7-4222-AE98-655548CC0E6D}"/>
+                <a16:creationId xmlns:a16="http://schemas.microsoft.com/office/drawing/2014/main" id="{311D0B84-50C2-4903-B451-C32DA4ECE671}"/>
               </a:ext>
             </a:extLst>
           </p:cNvPr>
@@ -12556,7 +12556,7 @@
           <p:cNvPr id="23" name="">
             <a:extLst xmlns:a="http://schemas.openxmlformats.org/drawingml/2006/main">
               <a:ext uri="{FF2B5EF4-FFF2-40B4-BE49-F238E27FC236}">
-                <a16:creationId xmlns:a16="http://schemas.microsoft.com/office/drawing/2014/main" id="{C6FB9CE4-ECD3-46FF-83B5-C3903E46579E}"/>
+                <a16:creationId xmlns:a16="http://schemas.microsoft.com/office/drawing/2014/main" id="{B94B2040-9F65-46F9-B640-C94E645C320E}"/>
               </a:ext>
             </a:extLst>
           </p:cNvPr>
@@ -12589,7 +12589,7 @@
           <p:cNvPr id="24" name="">
             <a:extLst xmlns:a="http://schemas.openxmlformats.org/drawingml/2006/main">
               <a:ext uri="{FF2B5EF4-FFF2-40B4-BE49-F238E27FC236}">
-                <a16:creationId xmlns:a16="http://schemas.microsoft.com/office/drawing/2014/main" id="{523B7ABD-1C59-41C4-AF06-2DA2BDA22DEC}"/>
+                <a16:creationId xmlns:a16="http://schemas.microsoft.com/office/drawing/2014/main" id="{405FF4EA-3B46-4213-B1D1-71A30D175129}"/>
               </a:ext>
             </a:extLst>
           </p:cNvPr>
@@ -12639,7 +12639,7 @@
           <p:cNvPr id="25" name="">
             <a:extLst xmlns:a="http://schemas.openxmlformats.org/drawingml/2006/main">
               <a:ext uri="{FF2B5EF4-FFF2-40B4-BE49-F238E27FC236}">
-                <a16:creationId xmlns:a16="http://schemas.microsoft.com/office/drawing/2014/main" id="{008FC67A-CF4C-4CE2-94CE-39931AB1BCE1}"/>
+                <a16:creationId xmlns:a16="http://schemas.microsoft.com/office/drawing/2014/main" id="{A5F4FA4B-1528-4E8A-86B6-8F05089ACC38}"/>
               </a:ext>
             </a:extLst>
           </p:cNvPr>
@@ -12672,7 +12672,7 @@
           <p:cNvPr id="26" name="">
             <a:extLst xmlns:a="http://schemas.openxmlformats.org/drawingml/2006/main">
               <a:ext uri="{FF2B5EF4-FFF2-40B4-BE49-F238E27FC236}">
-                <a16:creationId xmlns:a16="http://schemas.microsoft.com/office/drawing/2014/main" id="{A84F5AA6-8FDB-4C69-A2A2-C8E1088CC9F1}"/>
+                <a16:creationId xmlns:a16="http://schemas.microsoft.com/office/drawing/2014/main" id="{8B0A3EFD-897B-4BB9-9210-F33D073378D0}"/>
               </a:ext>
             </a:extLst>
           </p:cNvPr>
@@ -12722,7 +12722,7 @@
           <p:cNvPr id="27" name="">
             <a:extLst xmlns:a="http://schemas.openxmlformats.org/drawingml/2006/main">
               <a:ext uri="{FF2B5EF4-FFF2-40B4-BE49-F238E27FC236}">
-                <a16:creationId xmlns:a16="http://schemas.microsoft.com/office/drawing/2014/main" id="{842A65A7-853D-4543-AD4E-5822CD6C2140}"/>
+                <a16:creationId xmlns:a16="http://schemas.microsoft.com/office/drawing/2014/main" id="{C570523B-32C1-4316-9062-9816CFFDD7C9}"/>
               </a:ext>
             </a:extLst>
           </p:cNvPr>
@@ -12755,7 +12755,7 @@
           <p:cNvPr id="28" name="">
             <a:extLst xmlns:a="http://schemas.openxmlformats.org/drawingml/2006/main">
               <a:ext uri="{FF2B5EF4-FFF2-40B4-BE49-F238E27FC236}">
-                <a16:creationId xmlns:a16="http://schemas.microsoft.com/office/drawing/2014/main" id="{9077CE6F-2D7F-4254-BCB8-8F4E37591FBA}"/>
+                <a16:creationId xmlns:a16="http://schemas.microsoft.com/office/drawing/2014/main" id="{A588E9A9-EFBC-4759-9AB9-B11777B82A02}"/>
               </a:ext>
             </a:extLst>
           </p:cNvPr>
@@ -12805,7 +12805,7 @@
           <p:cNvPr id="29" name="">
             <a:extLst xmlns:a="http://schemas.openxmlformats.org/drawingml/2006/main">
               <a:ext uri="{FF2B5EF4-FFF2-40B4-BE49-F238E27FC236}">
-                <a16:creationId xmlns:a16="http://schemas.microsoft.com/office/drawing/2014/main" id="{4935C7BB-81EF-4FDC-8E36-0CDEF45E36C3}"/>
+                <a16:creationId xmlns:a16="http://schemas.microsoft.com/office/drawing/2014/main" id="{BD588C47-43BD-446E-BE59-72077887A9F2}"/>
               </a:ext>
             </a:extLst>
           </p:cNvPr>
@@ -12838,7 +12838,7 @@
           <p:cNvPr id="30" name="">
             <a:extLst xmlns:a="http://schemas.openxmlformats.org/drawingml/2006/main">
               <a:ext uri="{FF2B5EF4-FFF2-40B4-BE49-F238E27FC236}">
-                <a16:creationId xmlns:a16="http://schemas.microsoft.com/office/drawing/2014/main" id="{70622AD1-751A-4246-AAAE-2BE6C1B110C7}"/>
+                <a16:creationId xmlns:a16="http://schemas.microsoft.com/office/drawing/2014/main" id="{FDC6DC70-F241-49E9-86B2-1FD5D85F590A}"/>
               </a:ext>
             </a:extLst>
           </p:cNvPr>
@@ -12886,7 +12886,7 @@
     </p:spTree>
     <p:extLst>
       <p:ext uri="{BB962C8B-B14F-4D97-AF65-F5344CB8AC3E}">
-        <p14:creationId xmlns:p14="http://schemas.microsoft.com/office/powerpoint/2010/main" val="1548531679"/>
+        <p14:creationId xmlns:p14="http://schemas.microsoft.com/office/powerpoint/2010/main" val="1782528651"/>
       </p:ext>
     </p:extLst>
   </p:cSld>

</xml_diff>